<commit_message>
feat: LexAI Premium Update - Hybrid Routing, Smart Caching & Flash Briefing
- Implemented Hybrid Root Page: Automatic routing for Public vs Dashboard based on auth.

- Added LexAI Actions: 'Flash Briefing 60s' with intelligent caching for instant executive summaries.

- Integrated 'LexAI Assistant' Side Panel: Contextual chat and typewriter streaming effect.

- Performance Optimization: Parallel data fetching for dashboard and folders.

- UI/UX Overhaul: Premium Gold/Indigo branding, War Room Mode, and animated interactions.

- Database Update: Added aiSummary fields for caching logic.
</commit_message>
<xml_diff>
--- a/LexPremium_Presentation.pptx
+++ b/LexPremium_Presentation.pptx
@@ -19,10 +19,6 @@
     <p:sldId id="267" r:id="rId18"/>
     <p:sldId id="268" r:id="rId19"/>
     <p:sldId id="269" r:id="rId20"/>
-    <p:sldId id="270" r:id="rId21"/>
-    <p:sldId id="271" r:id="rId22"/>
-    <p:sldId id="272" r:id="rId23"/>
-    <p:sldId id="273" r:id="rId24"/>
   </p:sldIdLst>
   <p:sldSz cx="9144000" cy="6858000" type="screen4x3"/>
   <p:notesSz cx="6858000" cy="9144000"/>
@@ -3101,7 +3097,7 @@
     <p:bg>
       <p:bgPr>
         <a:solidFill>
-          <a:srgbClr val="1E293B"/>
+          <a:srgbClr val="000000"/>
         </a:solidFill>
         <a:effectLst/>
       </p:bgPr>
@@ -3131,7 +3127,7 @@
             <a:pPr>
               <a:defRPr b="1" sz="6000">
                 <a:solidFill>
-                  <a:srgbClr val="FBBF24"/>
+                  <a:srgbClr val="DAA520"/>
                 </a:solidFill>
               </a:defRPr>
             </a:pPr>
@@ -3157,47 +3153,23 @@
           <a:lstStyle/>
           <a:p>
             <a:pPr>
-              <a:defRPr>
+              <a:defRPr sz="2800">
                 <a:solidFill>
                   <a:srgbClr val="FFFFFF"/>
                 </a:solidFill>
               </a:defRPr>
             </a:pPr>
             <a:r>
-              <a:t>Solution de Gestion Intégrale &amp; IA Juridique</a:t>
-            </a:r>
-          </a:p>
-          <a:p>
-            <a:r>
-              <a:t>pour Cabinets d'Exception</a:t>
-            </a:r>
-          </a:p>
-        </p:txBody>
-      </p:sp>
-      <p:pic>
-        <p:nvPicPr>
-          <p:cNvPr id="4" name="Picture 3" descr="lexpremium_presentation_hero_1767228227038.png"/>
-          <p:cNvPicPr>
-            <a:picLocks noChangeAspect="1"/>
-          </p:cNvPicPr>
-          <p:nvPr/>
-        </p:nvPicPr>
-        <p:blipFill>
-          <a:blip r:embed="rId2"/>
-          <a:stretch>
-            <a:fillRect/>
-          </a:stretch>
-        </p:blipFill>
-        <p:spPr>
-          <a:xfrm>
-            <a:off x="4572000" y="2743200"/>
-            <a:ext cx="4114800" cy="4114800"/>
-          </a:xfrm>
-          <a:prstGeom prst="rect">
-            <a:avLst/>
-          </a:prstGeom>
-        </p:spPr>
-      </p:pic>
+              <a:t>L'Excellence Opérationnelle Augmentée</a:t>
+            </a:r>
+          </a:p>
+          <a:p>
+            <a:r>
+              <a:t>Design Signature : Or, Noir &amp; Rouge</a:t>
+            </a:r>
+          </a:p>
+        </p:txBody>
+      </p:sp>
     </p:spTree>
   </p:cSld>
   <p:clrMapOvr>
@@ -3212,7 +3184,7 @@
     <p:bg>
       <p:bgPr>
         <a:solidFill>
-          <a:srgbClr val="F1F5F9"/>
+          <a:srgbClr val="F8FAFC"/>
         </a:solidFill>
         <a:effectLst/>
       </p:bgPr>
@@ -3240,14 +3212,14 @@
           <a:lstStyle/>
           <a:p>
             <a:pPr>
-              <a:defRPr>
-                <a:solidFill>
-                  <a:srgbClr val="1E293B"/>
+              <a:defRPr b="1" sz="3600">
+                <a:solidFill>
+                  <a:srgbClr val="DAA520"/>
                 </a:solidFill>
               </a:defRPr>
             </a:pPr>
             <a:r>
-              <a:t>La Bible des Modèles</a:t>
+              <a:t>Gestion RH : Le Pilotage des Talents</a:t>
             </a:r>
           </a:p>
         </p:txBody>
@@ -3269,50 +3241,183 @@
           <a:p/>
           <a:p>
             <a:pPr>
-              <a:defRPr sz="2000">
-                <a:solidFill>
-                  <a:srgbClr val="334155"/>
+              <a:spcAft>
+                <a:spcPts val="1200"/>
+              </a:spcAft>
+              <a:defRPr sz="1900">
+                <a:solidFill>
+                  <a:srgbClr val="0F172A"/>
                 </a:solidFill>
               </a:defRPr>
             </a:pPr>
             <a:r>
-              <a:t>Standardisation de l'excellence rédactionnelle.</a:t>
+              <a:t>◈ Suivi des Collaborateurs : Parcours, expertises et gestion de la charge.</a:t>
             </a:r>
           </a:p>
           <a:p>
             <a:pPr>
-              <a:defRPr sz="2000">
-                <a:solidFill>
-                  <a:srgbClr val="334155"/>
+              <a:spcAft>
+                <a:spcPts val="1200"/>
+              </a:spcAft>
+              <a:defRPr sz="1900">
+                <a:solidFill>
+                  <a:srgbClr val="0F172A"/>
                 </a:solidFill>
               </a:defRPr>
             </a:pPr>
             <a:r>
-              <a:t>Générateur d'actes : Remplissage auto des données clients.</a:t>
+              <a:t>◈ Time-Tracking Prédictif : Analyse de la rentabilité par dossier et par avocat.</a:t>
             </a:r>
           </a:p>
           <a:p>
             <a:pPr>
-              <a:defRPr sz="2000">
-                <a:solidFill>
-                  <a:srgbClr val="334155"/>
+              <a:spcAft>
+                <a:spcPts val="1200"/>
+              </a:spcAft>
+              <a:defRPr sz="1900">
+                <a:solidFill>
+                  <a:srgbClr val="0F172A"/>
                 </a:solidFill>
               </a:defRPr>
             </a:pPr>
             <a:r>
-              <a:t>Bibliothèque de clauses sécurisées.</a:t>
+              <a:t>◈ Portail Staff : Congés, notes de frais et ressources RH centralisées.</a:t>
             </a:r>
           </a:p>
           <a:p>
             <a:pPr>
-              <a:defRPr sz="2000">
-                <a:solidFill>
-                  <a:srgbClr val="334155"/>
+              <a:spcAft>
+                <a:spcPts val="1200"/>
+              </a:spcAft>
+              <a:defRPr sz="1900">
+                <a:solidFill>
+                  <a:srgbClr val="0F172A"/>
                 </a:solidFill>
               </a:defRPr>
             </a:pPr>
             <a:r>
-              <a:t>Gain de temps de 70% sur la création d'actes.</a:t>
+              <a:t>◈ KPI Performance : Visualisez la croissance de votre équipe en temps réel.</a:t>
+            </a:r>
+          </a:p>
+        </p:txBody>
+      </p:sp>
+      <p:sp>
+        <p:nvSpPr>
+          <p:cNvPr id="4" name="Rectangle 3"/>
+          <p:cNvSpPr/>
+          <p:nvPr/>
+        </p:nvSpPr>
+        <p:spPr>
+          <a:xfrm>
+            <a:off x="0" y="0"/>
+            <a:ext cx="9144000" cy="731520"/>
+          </a:xfrm>
+          <a:prstGeom prst="rect">
+            <a:avLst/>
+          </a:prstGeom>
+          <a:solidFill>
+            <a:srgbClr val="0F172A"/>
+          </a:solidFill>
+          <a:ln>
+            <a:noFill/>
+          </a:ln>
+        </p:spPr>
+        <p:style>
+          <a:lnRef idx="1">
+            <a:schemeClr val="accent1"/>
+          </a:lnRef>
+          <a:fillRef idx="3">
+            <a:schemeClr val="accent1"/>
+          </a:fillRef>
+          <a:effectRef idx="2">
+            <a:schemeClr val="accent1"/>
+          </a:effectRef>
+          <a:fontRef idx="minor">
+            <a:schemeClr val="lt1"/>
+          </a:fontRef>
+        </p:style>
+        <p:txBody>
+          <a:bodyPr rtlCol="0" anchor="ctr"/>
+          <a:lstStyle/>
+          <a:p>
+            <a:pPr algn="ctr"/>
+          </a:p>
+        </p:txBody>
+      </p:sp>
+      <p:sp>
+        <p:nvSpPr>
+          <p:cNvPr id="5" name="Rectangle 4"/>
+          <p:cNvSpPr/>
+          <p:nvPr/>
+        </p:nvSpPr>
+        <p:spPr>
+          <a:xfrm>
+            <a:off x="0" y="731520"/>
+            <a:ext cx="182880" cy="6126480"/>
+          </a:xfrm>
+          <a:prstGeom prst="rect">
+            <a:avLst/>
+          </a:prstGeom>
+          <a:solidFill>
+            <a:srgbClr val="DC2626"/>
+          </a:solidFill>
+          <a:ln>
+            <a:noFill/>
+          </a:ln>
+        </p:spPr>
+        <p:style>
+          <a:lnRef idx="1">
+            <a:schemeClr val="accent1"/>
+          </a:lnRef>
+          <a:fillRef idx="3">
+            <a:schemeClr val="accent1"/>
+          </a:fillRef>
+          <a:effectRef idx="2">
+            <a:schemeClr val="accent1"/>
+          </a:effectRef>
+          <a:fontRef idx="minor">
+            <a:schemeClr val="lt1"/>
+          </a:fontRef>
+        </p:style>
+        <p:txBody>
+          <a:bodyPr rtlCol="0" anchor="ctr"/>
+          <a:lstStyle/>
+          <a:p>
+            <a:pPr algn="ctr"/>
+          </a:p>
+        </p:txBody>
+      </p:sp>
+      <p:sp>
+        <p:nvSpPr>
+          <p:cNvPr id="6" name="TextBox 5"/>
+          <p:cNvSpPr txBox="1"/>
+          <p:nvPr/>
+        </p:nvSpPr>
+        <p:spPr>
+          <a:xfrm>
+            <a:off x="548640" y="914400"/>
+            <a:ext cx="8229600" cy="457200"/>
+          </a:xfrm>
+          <a:prstGeom prst="rect">
+            <a:avLst/>
+          </a:prstGeom>
+          <a:noFill/>
+        </p:spPr>
+        <p:txBody>
+          <a:bodyPr wrap="none">
+            <a:spAutoFit/>
+          </a:bodyPr>
+          <a:lstStyle/>
+          <a:p>
+            <a:pPr>
+              <a:defRPr sz="1800" b="1">
+                <a:solidFill>
+                  <a:srgbClr val="0F172A"/>
+                </a:solidFill>
+              </a:defRPr>
+            </a:pPr>
+            <a:r>
+              <a:t>Optimisez votre Ressource la plus Précieuse</a:t>
             </a:r>
           </a:p>
         </p:txBody>
@@ -3331,7 +3436,7 @@
     <p:bg>
       <p:bgPr>
         <a:solidFill>
-          <a:srgbClr val="F1F5F9"/>
+          <a:srgbClr val="F8FAFC"/>
         </a:solidFill>
         <a:effectLst/>
       </p:bgPr>
@@ -3359,14 +3464,14 @@
           <a:lstStyle/>
           <a:p>
             <a:pPr>
-              <a:defRPr>
-                <a:solidFill>
-                  <a:srgbClr val="1E293B"/>
+              <a:defRPr b="1" sz="3600">
+                <a:solidFill>
+                  <a:srgbClr val="DAA520"/>
                 </a:solidFill>
               </a:defRPr>
             </a:pPr>
             <a:r>
-              <a:t>Comptabilité &amp; OHADA</a:t>
+              <a:t>Comptabilité Avancée SYSCOHADA</a:t>
             </a:r>
           </a:p>
         </p:txBody>
@@ -3388,50 +3493,183 @@
           <a:p/>
           <a:p>
             <a:pPr>
-              <a:defRPr sz="2000">
-                <a:solidFill>
-                  <a:srgbClr val="334155"/>
+              <a:spcAft>
+                <a:spcPts val="1200"/>
+              </a:spcAft>
+              <a:defRPr sz="1900">
+                <a:solidFill>
+                  <a:srgbClr val="0F172A"/>
                 </a:solidFill>
               </a:defRPr>
             </a:pPr>
             <a:r>
-              <a:t>Comptabilité intégrée (Achats, Ventes, Caisse).</a:t>
+              <a:t>◈ Écritures Automatiques : Générées dès la validation des factures.</a:t>
             </a:r>
           </a:p>
           <a:p>
             <a:pPr>
-              <a:defRPr sz="2000">
-                <a:solidFill>
-                  <a:srgbClr val="334155"/>
+              <a:spcAft>
+                <a:spcPts val="1200"/>
+              </a:spcAft>
+              <a:defRPr sz="1900">
+                <a:solidFill>
+                  <a:srgbClr val="0F172A"/>
                 </a:solidFill>
               </a:defRPr>
             </a:pPr>
             <a:r>
-              <a:t>Conformité SYSCOHADA garantie.</a:t>
+              <a:t>◈ Conformité OHADA : Grand Livre, Balance et Journaux complets.</a:t>
             </a:r>
           </a:p>
           <a:p>
             <a:pPr>
-              <a:defRPr sz="2000">
-                <a:solidFill>
-                  <a:srgbClr val="334155"/>
+              <a:spcAft>
+                <a:spcPts val="1200"/>
+              </a:spcAft>
+              <a:defRPr sz="1900">
+                <a:solidFill>
+                  <a:srgbClr val="0F172A"/>
                 </a:solidFill>
               </a:defRPr>
             </a:pPr>
             <a:r>
-              <a:t>Automatisation des écritures comptables.</a:t>
+              <a:t>◈ Gestion CARPA : Traçabilité totale des fonds tiers (Déontologie).</a:t>
             </a:r>
           </a:p>
           <a:p>
             <a:pPr>
-              <a:defRPr sz="2000">
-                <a:solidFill>
-                  <a:srgbClr val="334155"/>
+              <a:spcAft>
+                <a:spcPts val="1200"/>
+              </a:spcAft>
+              <a:defRPr sz="1900">
+                <a:solidFill>
+                  <a:srgbClr val="0F172A"/>
                 </a:solidFill>
               </a:defRPr>
             </a:pPr>
             <a:r>
-              <a:t>Historique des journaux inaltérable.</a:t>
+              <a:t>◈ Bilan &amp; Compte de Résultat : Vision financière instantanée pour les associés.</a:t>
+            </a:r>
+          </a:p>
+        </p:txBody>
+      </p:sp>
+      <p:sp>
+        <p:nvSpPr>
+          <p:cNvPr id="4" name="Rectangle 3"/>
+          <p:cNvSpPr/>
+          <p:nvPr/>
+        </p:nvSpPr>
+        <p:spPr>
+          <a:xfrm>
+            <a:off x="0" y="0"/>
+            <a:ext cx="9144000" cy="731520"/>
+          </a:xfrm>
+          <a:prstGeom prst="rect">
+            <a:avLst/>
+          </a:prstGeom>
+          <a:solidFill>
+            <a:srgbClr val="0F172A"/>
+          </a:solidFill>
+          <a:ln>
+            <a:noFill/>
+          </a:ln>
+        </p:spPr>
+        <p:style>
+          <a:lnRef idx="1">
+            <a:schemeClr val="accent1"/>
+          </a:lnRef>
+          <a:fillRef idx="3">
+            <a:schemeClr val="accent1"/>
+          </a:fillRef>
+          <a:effectRef idx="2">
+            <a:schemeClr val="accent1"/>
+          </a:effectRef>
+          <a:fontRef idx="minor">
+            <a:schemeClr val="lt1"/>
+          </a:fontRef>
+        </p:style>
+        <p:txBody>
+          <a:bodyPr rtlCol="0" anchor="ctr"/>
+          <a:lstStyle/>
+          <a:p>
+            <a:pPr algn="ctr"/>
+          </a:p>
+        </p:txBody>
+      </p:sp>
+      <p:sp>
+        <p:nvSpPr>
+          <p:cNvPr id="5" name="Rectangle 4"/>
+          <p:cNvSpPr/>
+          <p:nvPr/>
+        </p:nvSpPr>
+        <p:spPr>
+          <a:xfrm>
+            <a:off x="0" y="731520"/>
+            <a:ext cx="182880" cy="6126480"/>
+          </a:xfrm>
+          <a:prstGeom prst="rect">
+            <a:avLst/>
+          </a:prstGeom>
+          <a:solidFill>
+            <a:srgbClr val="DC2626"/>
+          </a:solidFill>
+          <a:ln>
+            <a:noFill/>
+          </a:ln>
+        </p:spPr>
+        <p:style>
+          <a:lnRef idx="1">
+            <a:schemeClr val="accent1"/>
+          </a:lnRef>
+          <a:fillRef idx="3">
+            <a:schemeClr val="accent1"/>
+          </a:fillRef>
+          <a:effectRef idx="2">
+            <a:schemeClr val="accent1"/>
+          </a:effectRef>
+          <a:fontRef idx="minor">
+            <a:schemeClr val="lt1"/>
+          </a:fontRef>
+        </p:style>
+        <p:txBody>
+          <a:bodyPr rtlCol="0" anchor="ctr"/>
+          <a:lstStyle/>
+          <a:p>
+            <a:pPr algn="ctr"/>
+          </a:p>
+        </p:txBody>
+      </p:sp>
+      <p:sp>
+        <p:nvSpPr>
+          <p:cNvPr id="6" name="TextBox 5"/>
+          <p:cNvSpPr txBox="1"/>
+          <p:nvPr/>
+        </p:nvSpPr>
+        <p:spPr>
+          <a:xfrm>
+            <a:off x="548640" y="914400"/>
+            <a:ext cx="8229600" cy="457200"/>
+          </a:xfrm>
+          <a:prstGeom prst="rect">
+            <a:avLst/>
+          </a:prstGeom>
+          <a:noFill/>
+        </p:spPr>
+        <p:txBody>
+          <a:bodyPr wrap="none">
+            <a:spAutoFit/>
+          </a:bodyPr>
+          <a:lstStyle/>
+          <a:p>
+            <a:pPr>
+              <a:defRPr sz="1800" b="1">
+                <a:solidFill>
+                  <a:srgbClr val="0F172A"/>
+                </a:solidFill>
+              </a:defRPr>
+            </a:pPr>
+            <a:r>
+              <a:t>La précision financière au service du Droit</a:t>
             </a:r>
           </a:p>
         </p:txBody>
@@ -3450,7 +3688,7 @@
     <p:bg>
       <p:bgPr>
         <a:solidFill>
-          <a:srgbClr val="F1F5F9"/>
+          <a:srgbClr val="000000"/>
         </a:solidFill>
         <a:effectLst/>
       </p:bgPr>
@@ -3478,80 +3716,72 @@
           <a:lstStyle/>
           <a:p>
             <a:pPr>
-              <a:defRPr>
-                <a:solidFill>
-                  <a:srgbClr val="1E293B"/>
+              <a:defRPr b="1" sz="5000">
+                <a:solidFill>
+                  <a:srgbClr val="B8860B"/>
                 </a:solidFill>
               </a:defRPr>
             </a:pPr>
             <a:r>
-              <a:t>Finance &amp; Pilotage</a:t>
-            </a:r>
-          </a:p>
-        </p:txBody>
-      </p:sp>
-      <p:sp>
-        <p:nvSpPr>
-          <p:cNvPr id="3" name="Content Placeholder 2"/>
-          <p:cNvSpPr>
-            <a:spLocks noGrp="1"/>
-          </p:cNvSpPr>
-          <p:nvPr>
-            <p:ph idx="1"/>
-          </p:nvPr>
-        </p:nvSpPr>
-        <p:spPr/>
-        <p:txBody>
-          <a:bodyPr wrap="square"/>
+              <a:t>TITRE IV : L'IA COMME AVANTAGE STRATÉGIQUE</a:t>
+            </a:r>
+          </a:p>
+        </p:txBody>
+      </p:sp>
+      <p:sp>
+        <p:nvSpPr>
+          <p:cNvPr id="3" name="Text Placeholder 2"/>
+          <p:cNvSpPr>
+            <a:spLocks noGrp="1"/>
+          </p:cNvSpPr>
+          <p:nvPr>
+            <p:ph type="body" idx="1"/>
+          </p:nvPr>
+        </p:nvSpPr>
+        <p:spPr/>
+        <p:txBody>
+          <a:bodyPr/>
           <a:lstStyle/>
           <a:p/>
-          <a:p>
-            <a:pPr>
-              <a:defRPr sz="2000">
-                <a:solidFill>
-                  <a:srgbClr val="334155"/>
-                </a:solidFill>
-              </a:defRPr>
-            </a:pPr>
-            <a:r>
-              <a:t>Pilotage stratégique par la donnée.</a:t>
-            </a:r>
-          </a:p>
-          <a:p>
-            <a:pPr>
-              <a:defRPr sz="2000">
-                <a:solidFill>
-                  <a:srgbClr val="334155"/>
-                </a:solidFill>
-              </a:defRPr>
-            </a:pPr>
-            <a:r>
-              <a:t>Gestion des CARPA (Fonds Tiers) sécurisée.</a:t>
-            </a:r>
-          </a:p>
-          <a:p>
-            <a:pPr>
-              <a:defRPr sz="2000">
-                <a:solidFill>
-                  <a:srgbClr val="334155"/>
-                </a:solidFill>
-              </a:defRPr>
-            </a:pPr>
-            <a:r>
-              <a:t>Rapports de rentabilité par collaborateur.</a:t>
-            </a:r>
-          </a:p>
-          <a:p>
-            <a:pPr>
-              <a:defRPr sz="2000">
-                <a:solidFill>
-                  <a:srgbClr val="334155"/>
-                </a:solidFill>
-              </a:defRPr>
-            </a:pPr>
-            <a:r>
-              <a:t>Suivi précis de la marge brute par dossier.</a:t>
-            </a:r>
+        </p:txBody>
+      </p:sp>
+      <p:sp>
+        <p:nvSpPr>
+          <p:cNvPr id="4" name="Rectangle 3"/>
+          <p:cNvSpPr/>
+          <p:nvPr/>
+        </p:nvSpPr>
+        <p:spPr>
+          <a:xfrm>
+            <a:off x="914400" y="4114800"/>
+            <a:ext cx="7315200" cy="73152"/>
+          </a:xfrm>
+          <a:prstGeom prst="rect">
+            <a:avLst/>
+          </a:prstGeom>
+          <a:solidFill>
+            <a:srgbClr val="DC2626"/>
+          </a:solidFill>
+        </p:spPr>
+        <p:style>
+          <a:lnRef idx="1">
+            <a:schemeClr val="accent1"/>
+          </a:lnRef>
+          <a:fillRef idx="3">
+            <a:schemeClr val="accent1"/>
+          </a:fillRef>
+          <a:effectRef idx="2">
+            <a:schemeClr val="accent1"/>
+          </a:effectRef>
+          <a:fontRef idx="minor">
+            <a:schemeClr val="lt1"/>
+          </a:fontRef>
+        </p:style>
+        <p:txBody>
+          <a:bodyPr rtlCol="0" anchor="ctr"/>
+          <a:lstStyle/>
+          <a:p>
+            <a:pPr algn="ctr"/>
           </a:p>
         </p:txBody>
       </p:sp>
@@ -3569,7 +3799,7 @@
     <p:bg>
       <p:bgPr>
         <a:solidFill>
-          <a:srgbClr val="F1F5F9"/>
+          <a:srgbClr val="F8FAFC"/>
         </a:solidFill>
         <a:effectLst/>
       </p:bgPr>
@@ -3597,14 +3827,14 @@
           <a:lstStyle/>
           <a:p>
             <a:pPr>
-              <a:defRPr>
-                <a:solidFill>
-                  <a:srgbClr val="1E293B"/>
+              <a:defRPr b="1" sz="3600">
+                <a:solidFill>
+                  <a:srgbClr val="DAA520"/>
                 </a:solidFill>
               </a:defRPr>
             </a:pPr>
             <a:r>
-              <a:t>Facturation &amp; Recouvrement</a:t>
+              <a:t>LexAI &amp; Scanner Adverse 2.0</a:t>
             </a:r>
           </a:p>
         </p:txBody>
@@ -3626,50 +3856,183 @@
           <a:p/>
           <a:p>
             <a:pPr>
-              <a:defRPr sz="2000">
-                <a:solidFill>
-                  <a:srgbClr val="334155"/>
+              <a:spcAft>
+                <a:spcPts val="1200"/>
+              </a:spcAft>
+              <a:defRPr sz="1900">
+                <a:solidFill>
+                  <a:srgbClr val="0F172A"/>
                 </a:solidFill>
               </a:defRPr>
             </a:pPr>
             <a:r>
-              <a:t>Émission de factures professionnelles en 3 clics.</a:t>
+              <a:t>◈ Analyse Éclair : 100 pages de conclusions scrutées en 60 secondes.</a:t>
             </a:r>
           </a:p>
           <a:p>
             <a:pPr>
-              <a:defRPr sz="2000">
-                <a:solidFill>
-                  <a:srgbClr val="334155"/>
+              <a:spcAft>
+                <a:spcPts val="1200"/>
+              </a:spcAft>
+              <a:defRPr sz="1900">
+                <a:solidFill>
+                  <a:srgbClr val="0F172A"/>
                 </a:solidFill>
               </a:defRPr>
             </a:pPr>
             <a:r>
-              <a:t>Suivi automatisé des relances pour impayés.</a:t>
+              <a:t>◈ Red Teaming : L'IA trouve les failles de votre propre défense.</a:t>
             </a:r>
           </a:p>
           <a:p>
             <a:pPr>
-              <a:defRPr sz="2000">
-                <a:solidFill>
-                  <a:srgbClr val="334155"/>
+              <a:spcAft>
+                <a:spcPts val="1200"/>
+              </a:spcAft>
+              <a:defRPr sz="1900">
+                <a:solidFill>
+                  <a:srgbClr val="0F172A"/>
                 </a:solidFill>
               </a:defRPr>
             </a:pPr>
             <a:r>
-              <a:t>Calculatrice d'intérêts moratoires intégrée.</a:t>
+              <a:t>◈ Jurisprudence de Riposte : Suggestions immédiates de contre-arguments.</a:t>
             </a:r>
           </a:p>
           <a:p>
             <a:pPr>
-              <a:defRPr sz="2000">
-                <a:solidFill>
-                  <a:srgbClr val="334155"/>
+              <a:spcAft>
+                <a:spcPts val="1200"/>
+              </a:spcAft>
+              <a:defRPr sz="1900">
+                <a:solidFill>
+                  <a:srgbClr val="0F172A"/>
                 </a:solidFill>
               </a:defRPr>
             </a:pPr>
             <a:r>
-              <a:t>Gestion des débours et honoraires séparée.</a:t>
+              <a:t>◈ Chat Juridique : Interrogez l'intelligence accumulée de vos dossiers.</a:t>
+            </a:r>
+          </a:p>
+        </p:txBody>
+      </p:sp>
+      <p:sp>
+        <p:nvSpPr>
+          <p:cNvPr id="4" name="Rectangle 3"/>
+          <p:cNvSpPr/>
+          <p:nvPr/>
+        </p:nvSpPr>
+        <p:spPr>
+          <a:xfrm>
+            <a:off x="0" y="0"/>
+            <a:ext cx="9144000" cy="731520"/>
+          </a:xfrm>
+          <a:prstGeom prst="rect">
+            <a:avLst/>
+          </a:prstGeom>
+          <a:solidFill>
+            <a:srgbClr val="0F172A"/>
+          </a:solidFill>
+          <a:ln>
+            <a:noFill/>
+          </a:ln>
+        </p:spPr>
+        <p:style>
+          <a:lnRef idx="1">
+            <a:schemeClr val="accent1"/>
+          </a:lnRef>
+          <a:fillRef idx="3">
+            <a:schemeClr val="accent1"/>
+          </a:fillRef>
+          <a:effectRef idx="2">
+            <a:schemeClr val="accent1"/>
+          </a:effectRef>
+          <a:fontRef idx="minor">
+            <a:schemeClr val="lt1"/>
+          </a:fontRef>
+        </p:style>
+        <p:txBody>
+          <a:bodyPr rtlCol="0" anchor="ctr"/>
+          <a:lstStyle/>
+          <a:p>
+            <a:pPr algn="ctr"/>
+          </a:p>
+        </p:txBody>
+      </p:sp>
+      <p:sp>
+        <p:nvSpPr>
+          <p:cNvPr id="5" name="Rectangle 4"/>
+          <p:cNvSpPr/>
+          <p:nvPr/>
+        </p:nvSpPr>
+        <p:spPr>
+          <a:xfrm>
+            <a:off x="0" y="731520"/>
+            <a:ext cx="182880" cy="6126480"/>
+          </a:xfrm>
+          <a:prstGeom prst="rect">
+            <a:avLst/>
+          </a:prstGeom>
+          <a:solidFill>
+            <a:srgbClr val="DC2626"/>
+          </a:solidFill>
+          <a:ln>
+            <a:noFill/>
+          </a:ln>
+        </p:spPr>
+        <p:style>
+          <a:lnRef idx="1">
+            <a:schemeClr val="accent1"/>
+          </a:lnRef>
+          <a:fillRef idx="3">
+            <a:schemeClr val="accent1"/>
+          </a:fillRef>
+          <a:effectRef idx="2">
+            <a:schemeClr val="accent1"/>
+          </a:effectRef>
+          <a:fontRef idx="minor">
+            <a:schemeClr val="lt1"/>
+          </a:fontRef>
+        </p:style>
+        <p:txBody>
+          <a:bodyPr rtlCol="0" anchor="ctr"/>
+          <a:lstStyle/>
+          <a:p>
+            <a:pPr algn="ctr"/>
+          </a:p>
+        </p:txBody>
+      </p:sp>
+      <p:sp>
+        <p:nvSpPr>
+          <p:cNvPr id="6" name="TextBox 5"/>
+          <p:cNvSpPr txBox="1"/>
+          <p:nvPr/>
+        </p:nvSpPr>
+        <p:spPr>
+          <a:xfrm>
+            <a:off x="548640" y="914400"/>
+            <a:ext cx="8229600" cy="457200"/>
+          </a:xfrm>
+          <a:prstGeom prst="rect">
+            <a:avLst/>
+          </a:prstGeom>
+          <a:noFill/>
+        </p:spPr>
+        <p:txBody>
+          <a:bodyPr wrap="none">
+            <a:spAutoFit/>
+          </a:bodyPr>
+          <a:lstStyle/>
+          <a:p>
+            <a:pPr>
+              <a:defRPr sz="1800" b="1">
+                <a:solidFill>
+                  <a:srgbClr val="0F172A"/>
+                </a:solidFill>
+              </a:defRPr>
+            </a:pPr>
+            <a:r>
+              <a:t>Désarmez l'opposition instantanément</a:t>
             </a:r>
           </a:p>
         </p:txBody>
@@ -3688,7 +4051,7 @@
     <p:bg>
       <p:bgPr>
         <a:solidFill>
-          <a:srgbClr val="F1F5F9"/>
+          <a:srgbClr val="000000"/>
         </a:solidFill>
         <a:effectLst/>
       </p:bgPr>
@@ -3707,7 +4070,7 @@
             <a:spLocks noGrp="1"/>
           </p:cNvSpPr>
           <p:nvPr>
-            <p:ph type="title"/>
+            <p:ph type="ctrTitle"/>
           </p:nvPr>
         </p:nvSpPr>
         <p:spPr/>
@@ -3716,523 +4079,52 @@
           <a:lstStyle/>
           <a:p>
             <a:pPr>
-              <a:defRPr>
-                <a:solidFill>
-                  <a:srgbClr val="1E293B"/>
+              <a:defRPr b="1" sz="6000">
+                <a:solidFill>
+                  <a:srgbClr val="DAA520"/>
                 </a:solidFill>
               </a:defRPr>
             </a:pPr>
             <a:r>
-              <a:t>Agenda &amp; Délais</a:t>
-            </a:r>
-          </a:p>
-        </p:txBody>
-      </p:sp>
-      <p:sp>
-        <p:nvSpPr>
-          <p:cNvPr id="3" name="Content Placeholder 2"/>
-          <p:cNvSpPr>
-            <a:spLocks noGrp="1"/>
-          </p:cNvSpPr>
-          <p:nvPr>
-            <p:ph idx="1"/>
-          </p:nvPr>
-        </p:nvSpPr>
-        <p:spPr/>
-        <p:txBody>
-          <a:bodyPr wrap="square"/>
-          <a:lstStyle/>
-          <a:p/>
+              <a:t>DOMINEZ VOTRE AVENIR</a:t>
+            </a:r>
+          </a:p>
+        </p:txBody>
+      </p:sp>
+      <p:sp>
+        <p:nvSpPr>
+          <p:cNvPr id="3" name="Subtitle 2"/>
+          <p:cNvSpPr>
+            <a:spLocks noGrp="1"/>
+          </p:cNvSpPr>
+          <p:nvPr>
+            <p:ph type="subTitle" idx="1"/>
+          </p:nvPr>
+        </p:nvSpPr>
+        <p:spPr/>
+        <p:txBody>
+          <a:bodyPr/>
+          <a:lstStyle/>
           <a:p>
             <a:pPr>
-              <a:defRPr sz="2000">
-                <a:solidFill>
-                  <a:srgbClr val="334155"/>
+              <a:defRPr sz="2800">
+                <a:solidFill>
+                  <a:srgbClr val="FFFFFF"/>
                 </a:solidFill>
               </a:defRPr>
             </a:pPr>
             <a:r>
-              <a:t>Calculateur automatique de délais de procédure.</a:t>
-            </a:r>
-          </a:p>
-          <a:p>
-            <a:pPr>
-              <a:defRPr sz="2000">
-                <a:solidFill>
-                  <a:srgbClr val="334155"/>
-                </a:solidFill>
-              </a:defRPr>
-            </a:pPr>
-            <a:r>
-              <a:t>Synchronisation smartphone globale.</a:t>
-            </a:r>
-          </a:p>
-          <a:p>
-            <a:pPr>
-              <a:defRPr sz="2000">
-                <a:solidFill>
-                  <a:srgbClr val="334155"/>
-                </a:solidFill>
-              </a:defRPr>
-            </a:pPr>
-            <a:r>
-              <a:t>Agenda d'équipe partagé par juridiction.</a:t>
-            </a:r>
-          </a:p>
-          <a:p>
-            <a:pPr>
-              <a:defRPr sz="2000">
-                <a:solidFill>
-                  <a:srgbClr val="334155"/>
-                </a:solidFill>
-              </a:defRPr>
-            </a:pPr>
-            <a:r>
-              <a:t>Alertes forclusion intelligentes.</a:t>
-            </a:r>
-          </a:p>
-        </p:txBody>
-      </p:sp>
-    </p:spTree>
-  </p:cSld>
-  <p:clrMapOvr>
-    <a:masterClrMapping/>
-  </p:clrMapOvr>
-</p:sld>
-</file>
-
-<file path=ppt/slides/slide15.xml><?xml version="1.0" encoding="utf-8"?>
-<p:sld xmlns:a="http://schemas.openxmlformats.org/drawingml/2006/main" xmlns:p="http://schemas.openxmlformats.org/presentationml/2006/main" xmlns:r="http://schemas.openxmlformats.org/officeDocument/2006/relationships">
-  <p:cSld>
-    <p:bg>
-      <p:bgPr>
-        <a:solidFill>
-          <a:srgbClr val="F1F5F9"/>
-        </a:solidFill>
-        <a:effectLst/>
-      </p:bgPr>
-    </p:bg>
-    <p:spTree>
-      <p:nvGrpSpPr>
-        <p:cNvPr id="1" name=""/>
-        <p:cNvGrpSpPr/>
-        <p:nvPr/>
-      </p:nvGrpSpPr>
-      <p:grpSpPr/>
-      <p:sp>
-        <p:nvSpPr>
-          <p:cNvPr id="2" name="Title 1"/>
-          <p:cNvSpPr>
-            <a:spLocks noGrp="1"/>
-          </p:cNvSpPr>
-          <p:nvPr>
-            <p:ph type="title"/>
-          </p:nvPr>
-        </p:nvSpPr>
-        <p:spPr/>
-        <p:txBody>
-          <a:bodyPr/>
-          <a:lstStyle/>
-          <a:p>
-            <a:pPr>
-              <a:defRPr>
-                <a:solidFill>
-                  <a:srgbClr val="1E293B"/>
-                </a:solidFill>
-              </a:defRPr>
-            </a:pPr>
-            <a:r>
-              <a:t>Dictée Vocale IA</a:t>
-            </a:r>
-          </a:p>
-        </p:txBody>
-      </p:sp>
-      <p:sp>
-        <p:nvSpPr>
-          <p:cNvPr id="3" name="Content Placeholder 2"/>
-          <p:cNvSpPr>
-            <a:spLocks noGrp="1"/>
-          </p:cNvSpPr>
-          <p:nvPr>
-            <p:ph idx="1"/>
-          </p:nvPr>
-        </p:nvSpPr>
-        <p:spPr/>
-        <p:txBody>
-          <a:bodyPr wrap="square"/>
-          <a:lstStyle/>
-          <a:p/>
-          <a:p>
-            <a:pPr>
-              <a:defRPr sz="2000">
-                <a:solidFill>
-                  <a:srgbClr val="334155"/>
-                </a:solidFill>
-              </a:defRPr>
-            </a:pPr>
-            <a:r>
-              <a:t>Dictée haute précision (jargon juridique OHADA).</a:t>
-            </a:r>
-          </a:p>
-          <a:p>
-            <a:pPr>
-              <a:defRPr sz="2000">
-                <a:solidFill>
-                  <a:srgbClr val="334155"/>
-                </a:solidFill>
-              </a:defRPr>
-            </a:pPr>
-            <a:r>
-              <a:t>Transcription instantanée en brouillons d'actes.</a:t>
-            </a:r>
-          </a:p>
-          <a:p>
-            <a:pPr>
-              <a:defRPr sz="2000">
-                <a:solidFill>
-                  <a:srgbClr val="334155"/>
-                </a:solidFill>
-              </a:defRPr>
-            </a:pPr>
-            <a:r>
-              <a:t>Mobilité : Dictez vos notes dès la sortie d'audience.</a:t>
-            </a:r>
-          </a:p>
-          <a:p>
-            <a:pPr>
-              <a:defRPr sz="2000">
-                <a:solidFill>
-                  <a:srgbClr val="334155"/>
-                </a:solidFill>
-              </a:defRPr>
-            </a:pPr>
-            <a:r>
-              <a:t>Reconnaissance multi-locuteurs pour les réunions.</a:t>
-            </a:r>
-          </a:p>
-        </p:txBody>
-      </p:sp>
-    </p:spTree>
-  </p:cSld>
-  <p:clrMapOvr>
-    <a:masterClrMapping/>
-  </p:clrMapOvr>
-</p:sld>
-</file>
-
-<file path=ppt/slides/slide16.xml><?xml version="1.0" encoding="utf-8"?>
-<p:sld xmlns:a="http://schemas.openxmlformats.org/drawingml/2006/main" xmlns:p="http://schemas.openxmlformats.org/presentationml/2006/main" xmlns:r="http://schemas.openxmlformats.org/officeDocument/2006/relationships">
-  <p:cSld>
-    <p:bg>
-      <p:bgPr>
-        <a:solidFill>
-          <a:srgbClr val="F1F5F9"/>
-        </a:solidFill>
-        <a:effectLst/>
-      </p:bgPr>
-    </p:bg>
-    <p:spTree>
-      <p:nvGrpSpPr>
-        <p:cNvPr id="1" name=""/>
-        <p:cNvGrpSpPr/>
-        <p:nvPr/>
-      </p:nvGrpSpPr>
-      <p:grpSpPr/>
-      <p:sp>
-        <p:nvSpPr>
-          <p:cNvPr id="2" name="Title 1"/>
-          <p:cNvSpPr>
-            <a:spLocks noGrp="1"/>
-          </p:cNvSpPr>
-          <p:nvPr>
-            <p:ph type="title"/>
-          </p:nvPr>
-        </p:nvSpPr>
-        <p:spPr/>
-        <p:txBody>
-          <a:bodyPr/>
-          <a:lstStyle/>
-          <a:p>
-            <a:pPr>
-              <a:defRPr>
-                <a:solidFill>
-                  <a:srgbClr val="1E293B"/>
-                </a:solidFill>
-              </a:defRPr>
-            </a:pPr>
-            <a:r>
-              <a:t>Portail Client (Extranet)</a:t>
-            </a:r>
-          </a:p>
-        </p:txBody>
-      </p:sp>
-      <p:sp>
-        <p:nvSpPr>
-          <p:cNvPr id="3" name="Content Placeholder 2"/>
-          <p:cNvSpPr>
-            <a:spLocks noGrp="1"/>
-          </p:cNvSpPr>
-          <p:nvPr>
-            <p:ph idx="1"/>
-          </p:nvPr>
-        </p:nvSpPr>
-        <p:spPr/>
-        <p:txBody>
-          <a:bodyPr wrap="square"/>
-          <a:lstStyle/>
-          <a:p/>
-          <a:p>
-            <a:pPr>
-              <a:defRPr sz="2000">
-                <a:solidFill>
-                  <a:srgbClr val="334155"/>
-                </a:solidFill>
-              </a:defRPr>
-            </a:pPr>
-            <a:r>
-              <a:t>Espace sécurisé dédié pour chaque client.</a:t>
-            </a:r>
-          </a:p>
-          <a:p>
-            <a:pPr>
-              <a:defRPr sz="2000">
-                <a:solidFill>
-                  <a:srgbClr val="334155"/>
-                </a:solidFill>
-              </a:defRPr>
-            </a:pPr>
-            <a:r>
-              <a:t>Suivi de l'avancement du dossier 24h/24.</a:t>
-            </a:r>
-          </a:p>
-          <a:p>
-            <a:pPr>
-              <a:defRPr sz="2000">
-                <a:solidFill>
-                  <a:srgbClr val="334155"/>
-                </a:solidFill>
-              </a:defRPr>
-            </a:pPr>
-            <a:r>
-              <a:t>Dépôt de pièces sécurisé (Fin des emails lourds).</a:t>
-            </a:r>
-          </a:p>
-          <a:p>
-            <a:pPr>
-              <a:defRPr sz="2000">
-                <a:solidFill>
-                  <a:srgbClr val="334155"/>
-                </a:solidFill>
-              </a:defRPr>
-            </a:pPr>
-            <a:r>
-              <a:t>Paiement des provisions en ligne.</a:t>
-            </a:r>
-          </a:p>
-        </p:txBody>
-      </p:sp>
-    </p:spTree>
-  </p:cSld>
-  <p:clrMapOvr>
-    <a:masterClrMapping/>
-  </p:clrMapOvr>
-</p:sld>
-</file>
-
-<file path=ppt/slides/slide17.xml><?xml version="1.0" encoding="utf-8"?>
-<p:sld xmlns:a="http://schemas.openxmlformats.org/drawingml/2006/main" xmlns:p="http://schemas.openxmlformats.org/presentationml/2006/main" xmlns:r="http://schemas.openxmlformats.org/officeDocument/2006/relationships">
-  <p:cSld>
-    <p:bg>
-      <p:bgPr>
-        <a:solidFill>
-          <a:srgbClr val="F1F5F9"/>
-        </a:solidFill>
-        <a:effectLst/>
-      </p:bgPr>
-    </p:bg>
-    <p:spTree>
-      <p:nvGrpSpPr>
-        <p:cNvPr id="1" name=""/>
-        <p:cNvGrpSpPr/>
-        <p:nvPr/>
-      </p:nvGrpSpPr>
-      <p:grpSpPr/>
-      <p:sp>
-        <p:nvSpPr>
-          <p:cNvPr id="2" name="Title 1"/>
-          <p:cNvSpPr>
-            <a:spLocks noGrp="1"/>
-          </p:cNvSpPr>
-          <p:nvPr>
-            <p:ph type="title"/>
-          </p:nvPr>
-        </p:nvSpPr>
-        <p:spPr/>
-        <p:txBody>
-          <a:bodyPr/>
-          <a:lstStyle/>
-          <a:p>
-            <a:pPr>
-              <a:defRPr>
-                <a:solidFill>
-                  <a:srgbClr val="1E293B"/>
-                </a:solidFill>
-              </a:defRPr>
-            </a:pPr>
-            <a:r>
-              <a:t>Cartographie Sémantique</a:t>
-            </a:r>
-          </a:p>
-        </p:txBody>
-      </p:sp>
-      <p:sp>
-        <p:nvSpPr>
-          <p:cNvPr id="3" name="Content Placeholder 2"/>
-          <p:cNvSpPr>
-            <a:spLocks noGrp="1"/>
-          </p:cNvSpPr>
-          <p:nvPr>
-            <p:ph idx="1"/>
-          </p:nvPr>
-        </p:nvSpPr>
-        <p:spPr/>
-        <p:txBody>
-          <a:bodyPr wrap="square"/>
-          <a:lstStyle/>
-          <a:p/>
-          <a:p>
-            <a:pPr>
-              <a:defRPr sz="2000">
-                <a:solidFill>
-                  <a:srgbClr val="334155"/>
-                </a:solidFill>
-              </a:defRPr>
-            </a:pPr>
-            <a:r>
-              <a:t>Visualisation des liens complexes d'un dossier.</a:t>
-            </a:r>
-          </a:p>
-          <a:p>
-            <a:pPr>
-              <a:defRPr sz="2000">
-                <a:solidFill>
-                  <a:srgbClr val="334155"/>
-                </a:solidFill>
-              </a:defRPr>
-            </a:pPr>
-            <a:r>
-              <a:t>Frise chronologique des faits clés générée par l'IA.</a:t>
-            </a:r>
-          </a:p>
-          <a:p>
-            <a:pPr>
-              <a:defRPr sz="2000">
-                <a:solidFill>
-                  <a:srgbClr val="334155"/>
-                </a:solidFill>
-              </a:defRPr>
-            </a:pPr>
-            <a:r>
-              <a:t>Détection visuelle des incohérences.</a:t>
-            </a:r>
-          </a:p>
-          <a:p>
-            <a:pPr>
-              <a:defRPr sz="2000">
-                <a:solidFill>
-                  <a:srgbClr val="334155"/>
-                </a:solidFill>
-              </a:defRPr>
-            </a:pPr>
-            <a:r>
-              <a:t>Outil d'aide à la décision stratégique.</a:t>
-            </a:r>
-          </a:p>
-        </p:txBody>
-      </p:sp>
-    </p:spTree>
-  </p:cSld>
-  <p:clrMapOvr>
-    <a:masterClrMapping/>
-  </p:clrMapOvr>
-</p:sld>
-</file>
-
-<file path=ppt/slides/slide18.xml><?xml version="1.0" encoding="utf-8"?>
-<p:sld xmlns:a="http://schemas.openxmlformats.org/drawingml/2006/main" xmlns:p="http://schemas.openxmlformats.org/presentationml/2006/main" xmlns:r="http://schemas.openxmlformats.org/officeDocument/2006/relationships">
-  <p:cSld>
-    <p:bg>
-      <p:bgPr>
-        <a:solidFill>
-          <a:srgbClr val="1E293B"/>
-        </a:solidFill>
-        <a:effectLst/>
-      </p:bgPr>
-    </p:bg>
-    <p:spTree>
-      <p:nvGrpSpPr>
-        <p:cNvPr id="1" name=""/>
-        <p:cNvGrpSpPr/>
-        <p:nvPr/>
-      </p:nvGrpSpPr>
-      <p:grpSpPr/>
-      <p:sp>
-        <p:nvSpPr>
-          <p:cNvPr id="2" name="Title 1"/>
-          <p:cNvSpPr>
-            <a:spLocks noGrp="1"/>
-          </p:cNvSpPr>
-          <p:nvPr>
-            <p:ph type="ctrTitle"/>
-          </p:nvPr>
-        </p:nvSpPr>
-        <p:spPr/>
-        <p:txBody>
-          <a:bodyPr/>
-          <a:lstStyle/>
-          <a:p>
-            <a:pPr>
-              <a:defRPr>
-                <a:solidFill>
-                  <a:srgbClr val="FBBF24"/>
-                </a:solidFill>
-              </a:defRPr>
-            </a:pPr>
-            <a:r>
-              <a:t>Choisissez l'Avenir.</a:t>
-            </a:r>
-          </a:p>
-        </p:txBody>
-      </p:sp>
-      <p:sp>
-        <p:nvSpPr>
-          <p:cNvPr id="3" name="Subtitle 2"/>
-          <p:cNvSpPr>
-            <a:spLocks noGrp="1"/>
-          </p:cNvSpPr>
-          <p:nvPr>
-            <p:ph type="subTitle" idx="1"/>
-          </p:nvPr>
-        </p:nvSpPr>
-        <p:spPr/>
-        <p:txBody>
-          <a:bodyPr/>
-          <a:lstStyle/>
-          <a:p>
-            <a:pPr>
-              <a:defRPr>
-                <a:solidFill>
-                  <a:srgbClr val="FFFFFF"/>
-                </a:solidFill>
-              </a:defRPr>
-            </a:pPr>
-            <a:r>
-              <a:t>LexPremium - L'IA au service du Droit</a:t>
+              <a:t>LexPremium 2026</a:t>
             </a:r>
           </a:p>
           <a:p>
             <a:r>
               <a:t>Démo : avocat-tito.vercel.app</a:t>
+            </a:r>
+          </a:p>
+          <a:p>
+            <a:r>
+              <a:t>Contact : contact@lexpremium.sn</a:t>
             </a:r>
           </a:p>
         </p:txBody>
@@ -4251,7 +4143,7 @@
     <p:bg>
       <p:bgPr>
         <a:solidFill>
-          <a:srgbClr val="F1F5F9"/>
+          <a:srgbClr val="F8FAFC"/>
         </a:solidFill>
         <a:effectLst/>
       </p:bgPr>
@@ -4279,14 +4171,14 @@
           <a:lstStyle/>
           <a:p>
             <a:pPr>
-              <a:defRPr>
-                <a:solidFill>
-                  <a:srgbClr val="1E293B"/>
+              <a:defRPr b="1" sz="3600">
+                <a:solidFill>
+                  <a:srgbClr val="DAA520"/>
                 </a:solidFill>
               </a:defRPr>
             </a:pPr>
             <a:r>
-              <a:t>Le Contexte : Les Défis du Barreau</a:t>
+              <a:t>L'Écosystème Global</a:t>
             </a:r>
           </a:p>
         </p:txBody>
@@ -4308,50 +4200,198 @@
           <a:p/>
           <a:p>
             <a:pPr>
-              <a:defRPr sz="2000">
-                <a:solidFill>
-                  <a:srgbClr val="334155"/>
+              <a:spcAft>
+                <a:spcPts val="1200"/>
+              </a:spcAft>
+              <a:defRPr sz="1900">
+                <a:solidFill>
+                  <a:srgbClr val="0F172A"/>
                 </a:solidFill>
               </a:defRPr>
             </a:pPr>
             <a:r>
-              <a:t>Fragmentation : Trop d'outils, données éparpillées.</a:t>
+              <a:t>◈ Gestion Juridique &amp; IA : Dossiers, LexAI, Scan Adverse.</a:t>
             </a:r>
           </a:p>
           <a:p>
             <a:pPr>
-              <a:defRPr sz="2000">
-                <a:solidFill>
-                  <a:srgbClr val="334155"/>
+              <a:spcAft>
+                <a:spcPts val="1200"/>
+              </a:spcAft>
+              <a:defRPr sz="1900">
+                <a:solidFill>
+                  <a:srgbClr val="0F172A"/>
                 </a:solidFill>
               </a:defRPr>
             </a:pPr>
             <a:r>
-              <a:t>Perte de Temps : 30% du temps d'un avocat est administratif.</a:t>
+              <a:t>◈ Documentation &amp; Bible : Modèles d'élite, Aide à la rédaction.</a:t>
             </a:r>
           </a:p>
           <a:p>
             <a:pPr>
-              <a:defRPr sz="2000">
-                <a:solidFill>
-                  <a:srgbClr val="334155"/>
+              <a:spcAft>
+                <a:spcPts val="1200"/>
+              </a:spcAft>
+              <a:defRPr sz="1900">
+                <a:solidFill>
+                  <a:srgbClr val="0F172A"/>
                 </a:solidFill>
               </a:defRPr>
             </a:pPr>
             <a:r>
-              <a:t>Sécurité : Risques croissants sur la confidentialité.</a:t>
+              <a:t>◈ Finance &amp; Compta : Standard SYSCOHADA, CARPA, Facturation.</a:t>
             </a:r>
           </a:p>
           <a:p>
             <a:pPr>
-              <a:defRPr sz="2000">
-                <a:solidFill>
-                  <a:srgbClr val="334155"/>
+              <a:spcAft>
+                <a:spcPts val="1200"/>
+              </a:spcAft>
+              <a:defRPr sz="1900">
+                <a:solidFill>
+                  <a:srgbClr val="0F172A"/>
                 </a:solidFill>
               </a:defRPr>
             </a:pPr>
             <a:r>
-              <a:t>Besoin d'IA : L'avantage compétitif indispensable.</a:t>
+              <a:t>◈ Ressources Humaines : Talents, Rentabilité, Portail Staff.</a:t>
+            </a:r>
+          </a:p>
+          <a:p>
+            <a:pPr>
+              <a:spcAft>
+                <a:spcPts val="1200"/>
+              </a:spcAft>
+              <a:defRPr sz="1900">
+                <a:solidFill>
+                  <a:srgbClr val="0F172A"/>
+                </a:solidFill>
+              </a:defRPr>
+            </a:pPr>
+            <a:r>
+              <a:t>◈ GED Élite : OCR, Archivage chiffré, Versioning.</a:t>
+            </a:r>
+          </a:p>
+        </p:txBody>
+      </p:sp>
+      <p:sp>
+        <p:nvSpPr>
+          <p:cNvPr id="4" name="Rectangle 3"/>
+          <p:cNvSpPr/>
+          <p:nvPr/>
+        </p:nvSpPr>
+        <p:spPr>
+          <a:xfrm>
+            <a:off x="0" y="0"/>
+            <a:ext cx="9144000" cy="731520"/>
+          </a:xfrm>
+          <a:prstGeom prst="rect">
+            <a:avLst/>
+          </a:prstGeom>
+          <a:solidFill>
+            <a:srgbClr val="0F172A"/>
+          </a:solidFill>
+          <a:ln>
+            <a:noFill/>
+          </a:ln>
+        </p:spPr>
+        <p:style>
+          <a:lnRef idx="1">
+            <a:schemeClr val="accent1"/>
+          </a:lnRef>
+          <a:fillRef idx="3">
+            <a:schemeClr val="accent1"/>
+          </a:fillRef>
+          <a:effectRef idx="2">
+            <a:schemeClr val="accent1"/>
+          </a:effectRef>
+          <a:fontRef idx="minor">
+            <a:schemeClr val="lt1"/>
+          </a:fontRef>
+        </p:style>
+        <p:txBody>
+          <a:bodyPr rtlCol="0" anchor="ctr"/>
+          <a:lstStyle/>
+          <a:p>
+            <a:pPr algn="ctr"/>
+          </a:p>
+        </p:txBody>
+      </p:sp>
+      <p:sp>
+        <p:nvSpPr>
+          <p:cNvPr id="5" name="Rectangle 4"/>
+          <p:cNvSpPr/>
+          <p:nvPr/>
+        </p:nvSpPr>
+        <p:spPr>
+          <a:xfrm>
+            <a:off x="0" y="731520"/>
+            <a:ext cx="182880" cy="6126480"/>
+          </a:xfrm>
+          <a:prstGeom prst="rect">
+            <a:avLst/>
+          </a:prstGeom>
+          <a:solidFill>
+            <a:srgbClr val="DC2626"/>
+          </a:solidFill>
+          <a:ln>
+            <a:noFill/>
+          </a:ln>
+        </p:spPr>
+        <p:style>
+          <a:lnRef idx="1">
+            <a:schemeClr val="accent1"/>
+          </a:lnRef>
+          <a:fillRef idx="3">
+            <a:schemeClr val="accent1"/>
+          </a:fillRef>
+          <a:effectRef idx="2">
+            <a:schemeClr val="accent1"/>
+          </a:effectRef>
+          <a:fontRef idx="minor">
+            <a:schemeClr val="lt1"/>
+          </a:fontRef>
+        </p:style>
+        <p:txBody>
+          <a:bodyPr rtlCol="0" anchor="ctr"/>
+          <a:lstStyle/>
+          <a:p>
+            <a:pPr algn="ctr"/>
+          </a:p>
+        </p:txBody>
+      </p:sp>
+      <p:sp>
+        <p:nvSpPr>
+          <p:cNvPr id="6" name="TextBox 5"/>
+          <p:cNvSpPr txBox="1"/>
+          <p:nvPr/>
+        </p:nvSpPr>
+        <p:spPr>
+          <a:xfrm>
+            <a:off x="548640" y="914400"/>
+            <a:ext cx="8229600" cy="457200"/>
+          </a:xfrm>
+          <a:prstGeom prst="rect">
+            <a:avLst/>
+          </a:prstGeom>
+          <a:noFill/>
+        </p:spPr>
+        <p:txBody>
+          <a:bodyPr wrap="none">
+            <a:spAutoFit/>
+          </a:bodyPr>
+          <a:lstStyle/>
+          <a:p>
+            <a:pPr>
+              <a:defRPr sz="1800" b="1">
+                <a:solidFill>
+                  <a:srgbClr val="0F172A"/>
+                </a:solidFill>
+              </a:defRPr>
+            </a:pPr>
+            <a:r>
+              <a:t>Une Vision à 360° du Cabinet Moderne</a:t>
             </a:r>
           </a:p>
         </p:txBody>
@@ -4370,7 +4410,7 @@
     <p:bg>
       <p:bgPr>
         <a:solidFill>
-          <a:srgbClr val="F1F5F9"/>
+          <a:srgbClr val="000000"/>
         </a:solidFill>
         <a:effectLst/>
       </p:bgPr>
@@ -4398,80 +4438,72 @@
           <a:lstStyle/>
           <a:p>
             <a:pPr>
-              <a:defRPr>
-                <a:solidFill>
-                  <a:srgbClr val="1E293B"/>
+              <a:defRPr b="1" sz="5000">
+                <a:solidFill>
+                  <a:srgbClr val="B8860B"/>
                 </a:solidFill>
               </a:defRPr>
             </a:pPr>
             <a:r>
-              <a:t>La Vision : L'Avocat Augmenté</a:t>
-            </a:r>
-          </a:p>
-        </p:txBody>
-      </p:sp>
-      <p:sp>
-        <p:nvSpPr>
-          <p:cNvPr id="3" name="Content Placeholder 2"/>
-          <p:cNvSpPr>
-            <a:spLocks noGrp="1"/>
-          </p:cNvSpPr>
-          <p:nvPr>
-            <p:ph idx="1"/>
-          </p:nvPr>
-        </p:nvSpPr>
-        <p:spPr/>
-        <p:txBody>
-          <a:bodyPr wrap="square"/>
+              <a:t>TITRE I : GED ÉLITE &amp; ARCHIVAGE</a:t>
+            </a:r>
+          </a:p>
+        </p:txBody>
+      </p:sp>
+      <p:sp>
+        <p:nvSpPr>
+          <p:cNvPr id="3" name="Text Placeholder 2"/>
+          <p:cNvSpPr>
+            <a:spLocks noGrp="1"/>
+          </p:cNvSpPr>
+          <p:nvPr>
+            <p:ph type="body" idx="1"/>
+          </p:nvPr>
+        </p:nvSpPr>
+        <p:spPr/>
+        <p:txBody>
+          <a:bodyPr/>
           <a:lstStyle/>
           <a:p/>
-          <a:p>
-            <a:pPr>
-              <a:defRPr sz="2000">
-                <a:solidFill>
-                  <a:srgbClr val="334155"/>
-                </a:solidFill>
-              </a:defRPr>
-            </a:pPr>
-            <a:r>
-              <a:t>Un cabinet 100% numérique, sécurisé et intelligent.</a:t>
-            </a:r>
-          </a:p>
-          <a:p>
-            <a:pPr>
-              <a:defRPr sz="2000">
-                <a:solidFill>
-                  <a:srgbClr val="334155"/>
-                </a:solidFill>
-              </a:defRPr>
-            </a:pPr>
-            <a:r>
-              <a:t>Centralisation totale des dossiers et de la finance.</a:t>
-            </a:r>
-          </a:p>
-          <a:p>
-            <a:pPr>
-              <a:defRPr sz="2000">
-                <a:solidFill>
-                  <a:srgbClr val="334155"/>
-                </a:solidFill>
-              </a:defRPr>
-            </a:pPr>
-            <a:r>
-              <a:t>L'IA au service de l'expertise juridique.</a:t>
-            </a:r>
-          </a:p>
-          <a:p>
-            <a:pPr>
-              <a:defRPr sz="2000">
-                <a:solidFill>
-                  <a:srgbClr val="334155"/>
-                </a:solidFill>
-              </a:defRPr>
-            </a:pPr>
-            <a:r>
-              <a:t>Libérez-vous des tâches répétitives.</a:t>
-            </a:r>
+        </p:txBody>
+      </p:sp>
+      <p:sp>
+        <p:nvSpPr>
+          <p:cNvPr id="4" name="Rectangle 3"/>
+          <p:cNvSpPr/>
+          <p:nvPr/>
+        </p:nvSpPr>
+        <p:spPr>
+          <a:xfrm>
+            <a:off x="914400" y="4114800"/>
+            <a:ext cx="7315200" cy="73152"/>
+          </a:xfrm>
+          <a:prstGeom prst="rect">
+            <a:avLst/>
+          </a:prstGeom>
+          <a:solidFill>
+            <a:srgbClr val="DC2626"/>
+          </a:solidFill>
+        </p:spPr>
+        <p:style>
+          <a:lnRef idx="1">
+            <a:schemeClr val="accent1"/>
+          </a:lnRef>
+          <a:fillRef idx="3">
+            <a:schemeClr val="accent1"/>
+          </a:fillRef>
+          <a:effectRef idx="2">
+            <a:schemeClr val="accent1"/>
+          </a:effectRef>
+          <a:fontRef idx="minor">
+            <a:schemeClr val="lt1"/>
+          </a:fontRef>
+        </p:style>
+        <p:txBody>
+          <a:bodyPr rtlCol="0" anchor="ctr"/>
+          <a:lstStyle/>
+          <a:p>
+            <a:pPr algn="ctr"/>
           </a:p>
         </p:txBody>
       </p:sp>
@@ -4489,7 +4521,7 @@
     <p:bg>
       <p:bgPr>
         <a:solidFill>
-          <a:srgbClr val="F1F5F9"/>
+          <a:srgbClr val="F8FAFC"/>
         </a:solidFill>
         <a:effectLst/>
       </p:bgPr>
@@ -4517,14 +4549,14 @@
           <a:lstStyle/>
           <a:p>
             <a:pPr>
-              <a:defRPr>
-                <a:solidFill>
-                  <a:srgbClr val="1E293B"/>
+              <a:defRPr b="1" sz="3600">
+                <a:solidFill>
+                  <a:srgbClr val="DAA520"/>
                 </a:solidFill>
               </a:defRPr>
             </a:pPr>
             <a:r>
-              <a:t>Pilotage Visionnaire</a:t>
+              <a:t>GED Élite : Maîtrise Documentaire</a:t>
             </a:r>
           </a:p>
         </p:txBody>
@@ -4546,50 +4578,183 @@
           <a:p/>
           <a:p>
             <a:pPr>
-              <a:defRPr sz="2000">
-                <a:solidFill>
-                  <a:srgbClr val="334155"/>
+              <a:spcAft>
+                <a:spcPts val="1200"/>
+              </a:spcAft>
+              <a:defRPr sz="1900">
+                <a:solidFill>
+                  <a:srgbClr val="0F172A"/>
                 </a:solidFill>
               </a:defRPr>
             </a:pPr>
             <a:r>
-              <a:t>Vue 360° : Dossiers, clients et alertes en un coup d'œil.</a:t>
+              <a:t>◈ Indexation Sémantique : Retrouvez n'importe quelle clause ou pièce par concept.</a:t>
             </a:r>
           </a:p>
           <a:p>
             <a:pPr>
-              <a:defRPr sz="2000">
-                <a:solidFill>
-                  <a:srgbClr val="334155"/>
+              <a:spcAft>
+                <a:spcPts val="1200"/>
+              </a:spcAft>
+              <a:defRPr sz="1900">
+                <a:solidFill>
+                  <a:srgbClr val="0F172A"/>
                 </a:solidFill>
               </a:defRPr>
             </a:pPr>
             <a:r>
-              <a:t>Indicateurs Financiers : CA et impayés en temps réel.</a:t>
+              <a:t>◈ OCR Haute-Résolution : Transformation immédiate des scans en textes vivants.</a:t>
             </a:r>
           </a:p>
           <a:p>
             <a:pPr>
-              <a:defRPr sz="2000">
-                <a:solidFill>
-                  <a:srgbClr val="334155"/>
+              <a:spcAft>
+                <a:spcPts val="1200"/>
+              </a:spcAft>
+              <a:defRPr sz="1900">
+                <a:solidFill>
+                  <a:srgbClr val="0F172A"/>
                 </a:solidFill>
               </a:defRPr>
             </a:pPr>
             <a:r>
-              <a:t>Priorisation IA : Identification des urgences.</a:t>
+              <a:t>◈ Coffre-Fort Numérique : Archivage chiffré (AES-256) des documents sensibles.</a:t>
             </a:r>
           </a:p>
           <a:p>
             <a:pPr>
-              <a:defRPr sz="2000">
-                <a:solidFill>
-                  <a:srgbClr val="334155"/>
+              <a:spcAft>
+                <a:spcPts val="1200"/>
+              </a:spcAft>
+              <a:defRPr sz="1900">
+                <a:solidFill>
+                  <a:srgbClr val="0F172A"/>
                 </a:solidFill>
               </a:defRPr>
             </a:pPr>
             <a:r>
-              <a:t>Interface tactile et intuitive.</a:t>
+              <a:t>◈ Zéro Papier : Libérez l'espace physique, saturez l'espace numérique sécurisé.</a:t>
+            </a:r>
+          </a:p>
+        </p:txBody>
+      </p:sp>
+      <p:sp>
+        <p:nvSpPr>
+          <p:cNvPr id="4" name="Rectangle 3"/>
+          <p:cNvSpPr/>
+          <p:nvPr/>
+        </p:nvSpPr>
+        <p:spPr>
+          <a:xfrm>
+            <a:off x="0" y="0"/>
+            <a:ext cx="9144000" cy="731520"/>
+          </a:xfrm>
+          <a:prstGeom prst="rect">
+            <a:avLst/>
+          </a:prstGeom>
+          <a:solidFill>
+            <a:srgbClr val="0F172A"/>
+          </a:solidFill>
+          <a:ln>
+            <a:noFill/>
+          </a:ln>
+        </p:spPr>
+        <p:style>
+          <a:lnRef idx="1">
+            <a:schemeClr val="accent1"/>
+          </a:lnRef>
+          <a:fillRef idx="3">
+            <a:schemeClr val="accent1"/>
+          </a:fillRef>
+          <a:effectRef idx="2">
+            <a:schemeClr val="accent1"/>
+          </a:effectRef>
+          <a:fontRef idx="minor">
+            <a:schemeClr val="lt1"/>
+          </a:fontRef>
+        </p:style>
+        <p:txBody>
+          <a:bodyPr rtlCol="0" anchor="ctr"/>
+          <a:lstStyle/>
+          <a:p>
+            <a:pPr algn="ctr"/>
+          </a:p>
+        </p:txBody>
+      </p:sp>
+      <p:sp>
+        <p:nvSpPr>
+          <p:cNvPr id="5" name="Rectangle 4"/>
+          <p:cNvSpPr/>
+          <p:nvPr/>
+        </p:nvSpPr>
+        <p:spPr>
+          <a:xfrm>
+            <a:off x="0" y="731520"/>
+            <a:ext cx="182880" cy="6126480"/>
+          </a:xfrm>
+          <a:prstGeom prst="rect">
+            <a:avLst/>
+          </a:prstGeom>
+          <a:solidFill>
+            <a:srgbClr val="DC2626"/>
+          </a:solidFill>
+          <a:ln>
+            <a:noFill/>
+          </a:ln>
+        </p:spPr>
+        <p:style>
+          <a:lnRef idx="1">
+            <a:schemeClr val="accent1"/>
+          </a:lnRef>
+          <a:fillRef idx="3">
+            <a:schemeClr val="accent1"/>
+          </a:fillRef>
+          <a:effectRef idx="2">
+            <a:schemeClr val="accent1"/>
+          </a:effectRef>
+          <a:fontRef idx="minor">
+            <a:schemeClr val="lt1"/>
+          </a:fontRef>
+        </p:style>
+        <p:txBody>
+          <a:bodyPr rtlCol="0" anchor="ctr"/>
+          <a:lstStyle/>
+          <a:p>
+            <a:pPr algn="ctr"/>
+          </a:p>
+        </p:txBody>
+      </p:sp>
+      <p:sp>
+        <p:nvSpPr>
+          <p:cNvPr id="6" name="TextBox 5"/>
+          <p:cNvSpPr txBox="1"/>
+          <p:nvPr/>
+        </p:nvSpPr>
+        <p:spPr>
+          <a:xfrm>
+            <a:off x="548640" y="914400"/>
+            <a:ext cx="8229600" cy="457200"/>
+          </a:xfrm>
+          <a:prstGeom prst="rect">
+            <a:avLst/>
+          </a:prstGeom>
+          <a:noFill/>
+        </p:spPr>
+        <p:txBody>
+          <a:bodyPr wrap="none">
+            <a:spAutoFit/>
+          </a:bodyPr>
+          <a:lstStyle/>
+          <a:p>
+            <a:pPr>
+              <a:defRPr sz="1800" b="1">
+                <a:solidFill>
+                  <a:srgbClr val="0F172A"/>
+                </a:solidFill>
+              </a:defRPr>
+            </a:pPr>
+            <a:r>
+              <a:t>Centralisation, Intelligence et Pérennité</a:t>
             </a:r>
           </a:p>
         </p:txBody>
@@ -4608,7 +4773,7 @@
     <p:bg>
       <p:bgPr>
         <a:solidFill>
-          <a:srgbClr val="F1F5F9"/>
+          <a:srgbClr val="F8FAFC"/>
         </a:solidFill>
         <a:effectLst/>
       </p:bgPr>
@@ -4636,14 +4801,14 @@
           <a:lstStyle/>
           <a:p>
             <a:pPr>
-              <a:defRPr>
-                <a:solidFill>
-                  <a:srgbClr val="1E293B"/>
+              <a:defRPr b="1" sz="3600">
+                <a:solidFill>
+                  <a:srgbClr val="DAA520"/>
                 </a:solidFill>
               </a:defRPr>
             </a:pPr>
             <a:r>
-              <a:t>LexAI : Votre Collaborateur 24h/24</a:t>
+              <a:t>Versioning &amp; Collaboration</a:t>
             </a:r>
           </a:p>
         </p:txBody>
@@ -4665,50 +4830,183 @@
           <a:p/>
           <a:p>
             <a:pPr>
-              <a:defRPr sz="2000">
-                <a:solidFill>
-                  <a:srgbClr val="334155"/>
+              <a:spcAft>
+                <a:spcPts val="1200"/>
+              </a:spcAft>
+              <a:defRPr sz="1900">
+                <a:solidFill>
+                  <a:srgbClr val="0F172A"/>
                 </a:solidFill>
               </a:defRPr>
             </a:pPr>
             <a:r>
-              <a:t>Chat Juridique : Questions en langage naturel.</a:t>
+              <a:t>◈ Traçabilité Dynamique : Suivez chaque modification d'acte (v1, v2, Final).</a:t>
             </a:r>
           </a:p>
           <a:p>
             <a:pPr>
-              <a:defRPr sz="2000">
-                <a:solidFill>
-                  <a:srgbClr val="334155"/>
+              <a:spcAft>
+                <a:spcPts val="1200"/>
+              </a:spcAft>
+              <a:defRPr sz="1900">
+                <a:solidFill>
+                  <a:srgbClr val="0F172A"/>
                 </a:solidFill>
               </a:defRPr>
             </a:pPr>
             <a:r>
-              <a:t>Synthèse Automatique : Résumé de documents volumineux.</a:t>
+              <a:t>◈ Comparateur IA : Identifiez visuellement les changements entre deux versions.</a:t>
             </a:r>
           </a:p>
           <a:p>
             <a:pPr>
-              <a:defRPr sz="2000">
-                <a:solidFill>
-                  <a:srgbClr val="334155"/>
+              <a:spcAft>
+                <a:spcPts val="1200"/>
+              </a:spcAft>
+              <a:defRPr sz="1900">
+                <a:solidFill>
+                  <a:srgbClr val="0F172A"/>
                 </a:solidFill>
               </a:defRPr>
             </a:pPr>
             <a:r>
-              <a:t>Analyse de Pièces : Extraction de données clés (dates, montants).</a:t>
+              <a:t>◈ Circuit de Validation : Signature numérique intégrée au flux GED.</a:t>
             </a:r>
           </a:p>
           <a:p>
             <a:pPr>
-              <a:defRPr sz="2000">
-                <a:solidFill>
-                  <a:srgbClr val="334155"/>
+              <a:spcAft>
+                <a:spcPts val="1200"/>
+              </a:spcAft>
+              <a:defRPr sz="1900">
+                <a:solidFill>
+                  <a:srgbClr val="0F172A"/>
                 </a:solidFill>
               </a:defRPr>
             </a:pPr>
             <a:r>
-              <a:t>Assistance à la rédaction permanente.</a:t>
+              <a:t>◈ Accès Multi-Supports : Vos pièces au cabinet, au tribunal ou à la maison.</a:t>
+            </a:r>
+          </a:p>
+        </p:txBody>
+      </p:sp>
+      <p:sp>
+        <p:nvSpPr>
+          <p:cNvPr id="4" name="Rectangle 3"/>
+          <p:cNvSpPr/>
+          <p:nvPr/>
+        </p:nvSpPr>
+        <p:spPr>
+          <a:xfrm>
+            <a:off x="0" y="0"/>
+            <a:ext cx="9144000" cy="731520"/>
+          </a:xfrm>
+          <a:prstGeom prst="rect">
+            <a:avLst/>
+          </a:prstGeom>
+          <a:solidFill>
+            <a:srgbClr val="0F172A"/>
+          </a:solidFill>
+          <a:ln>
+            <a:noFill/>
+          </a:ln>
+        </p:spPr>
+        <p:style>
+          <a:lnRef idx="1">
+            <a:schemeClr val="accent1"/>
+          </a:lnRef>
+          <a:fillRef idx="3">
+            <a:schemeClr val="accent1"/>
+          </a:fillRef>
+          <a:effectRef idx="2">
+            <a:schemeClr val="accent1"/>
+          </a:effectRef>
+          <a:fontRef idx="minor">
+            <a:schemeClr val="lt1"/>
+          </a:fontRef>
+        </p:style>
+        <p:txBody>
+          <a:bodyPr rtlCol="0" anchor="ctr"/>
+          <a:lstStyle/>
+          <a:p>
+            <a:pPr algn="ctr"/>
+          </a:p>
+        </p:txBody>
+      </p:sp>
+      <p:sp>
+        <p:nvSpPr>
+          <p:cNvPr id="5" name="Rectangle 4"/>
+          <p:cNvSpPr/>
+          <p:nvPr/>
+        </p:nvSpPr>
+        <p:spPr>
+          <a:xfrm>
+            <a:off x="0" y="731520"/>
+            <a:ext cx="182880" cy="6126480"/>
+          </a:xfrm>
+          <a:prstGeom prst="rect">
+            <a:avLst/>
+          </a:prstGeom>
+          <a:solidFill>
+            <a:srgbClr val="DC2626"/>
+          </a:solidFill>
+          <a:ln>
+            <a:noFill/>
+          </a:ln>
+        </p:spPr>
+        <p:style>
+          <a:lnRef idx="1">
+            <a:schemeClr val="accent1"/>
+          </a:lnRef>
+          <a:fillRef idx="3">
+            <a:schemeClr val="accent1"/>
+          </a:fillRef>
+          <a:effectRef idx="2">
+            <a:schemeClr val="accent1"/>
+          </a:effectRef>
+          <a:fontRef idx="minor">
+            <a:schemeClr val="lt1"/>
+          </a:fontRef>
+        </p:style>
+        <p:txBody>
+          <a:bodyPr rtlCol="0" anchor="ctr"/>
+          <a:lstStyle/>
+          <a:p>
+            <a:pPr algn="ctr"/>
+          </a:p>
+        </p:txBody>
+      </p:sp>
+      <p:sp>
+        <p:nvSpPr>
+          <p:cNvPr id="6" name="TextBox 5"/>
+          <p:cNvSpPr txBox="1"/>
+          <p:nvPr/>
+        </p:nvSpPr>
+        <p:spPr>
+          <a:xfrm>
+            <a:off x="548640" y="914400"/>
+            <a:ext cx="8229600" cy="457200"/>
+          </a:xfrm>
+          <a:prstGeom prst="rect">
+            <a:avLst/>
+          </a:prstGeom>
+          <a:noFill/>
+        </p:spPr>
+        <p:txBody>
+          <a:bodyPr wrap="none">
+            <a:spAutoFit/>
+          </a:bodyPr>
+          <a:lstStyle/>
+          <a:p>
+            <a:pPr>
+              <a:defRPr sz="1800" b="1">
+                <a:solidFill>
+                  <a:srgbClr val="0F172A"/>
+                </a:solidFill>
+              </a:defRPr>
+            </a:pPr>
+            <a:r>
+              <a:t>L'Historique est votre Meilleur Témoin</a:t>
             </a:r>
           </a:p>
         </p:txBody>
@@ -4727,7 +5025,7 @@
     <p:bg>
       <p:bgPr>
         <a:solidFill>
-          <a:srgbClr val="F1F5F9"/>
+          <a:srgbClr val="000000"/>
         </a:solidFill>
         <a:effectLst/>
       </p:bgPr>
@@ -4755,80 +5053,72 @@
           <a:lstStyle/>
           <a:p>
             <a:pPr>
-              <a:defRPr>
-                <a:solidFill>
-                  <a:srgbClr val="1E293B"/>
+              <a:defRPr b="1" sz="5000">
+                <a:solidFill>
+                  <a:srgbClr val="B8860B"/>
                 </a:solidFill>
               </a:defRPr>
             </a:pPr>
             <a:r>
-              <a:t>IA : Stratégie &amp; 'Red Teaming'</a:t>
-            </a:r>
-          </a:p>
-        </p:txBody>
-      </p:sp>
-      <p:sp>
-        <p:nvSpPr>
-          <p:cNvPr id="3" name="Content Placeholder 2"/>
-          <p:cNvSpPr>
-            <a:spLocks noGrp="1"/>
-          </p:cNvSpPr>
-          <p:nvPr>
-            <p:ph idx="1"/>
-          </p:nvPr>
-        </p:nvSpPr>
-        <p:spPr/>
-        <p:txBody>
-          <a:bodyPr wrap="square"/>
+              <a:t>TITRE II : BIBLE JURIDIQUE &amp; RÉDACTION</a:t>
+            </a:r>
+          </a:p>
+        </p:txBody>
+      </p:sp>
+      <p:sp>
+        <p:nvSpPr>
+          <p:cNvPr id="3" name="Text Placeholder 2"/>
+          <p:cNvSpPr>
+            <a:spLocks noGrp="1"/>
+          </p:cNvSpPr>
+          <p:nvPr>
+            <p:ph type="body" idx="1"/>
+          </p:nvPr>
+        </p:nvSpPr>
+        <p:spPr/>
+        <p:txBody>
+          <a:bodyPr/>
           <a:lstStyle/>
           <a:p/>
-          <a:p>
-            <a:pPr>
-              <a:defRPr sz="2000">
-                <a:solidFill>
-                  <a:srgbClr val="334155"/>
-                </a:solidFill>
-              </a:defRPr>
-            </a:pPr>
-            <a:r>
-              <a:t>Simulation d'Attaque : Identifiez les failles de votre argumentaire.</a:t>
-            </a:r>
-          </a:p>
-          <a:p>
-            <a:pPr>
-              <a:defRPr sz="2000">
-                <a:solidFill>
-                  <a:srgbClr val="334155"/>
-                </a:solidFill>
-              </a:defRPr>
-            </a:pPr>
-            <a:r>
-              <a:t>Générateur de Contre-Arguments : Anticipez la partie adverse.</a:t>
-            </a:r>
-          </a:p>
-          <a:p>
-            <a:pPr>
-              <a:defRPr sz="2000">
-                <a:solidFill>
-                  <a:srgbClr val="334155"/>
-                </a:solidFill>
-              </a:defRPr>
-            </a:pPr>
-            <a:r>
-              <a:t>Audit de contrats : Détectez les clauses risquées.</a:t>
-            </a:r>
-          </a:p>
-          <a:p>
-            <a:pPr>
-              <a:defRPr sz="2000">
-                <a:solidFill>
-                  <a:srgbClr val="334155"/>
-                </a:solidFill>
-              </a:defRPr>
-            </a:pPr>
-            <a:r>
-              <a:t>Optimisation de la stratégie de défense.</a:t>
-            </a:r>
+        </p:txBody>
+      </p:sp>
+      <p:sp>
+        <p:nvSpPr>
+          <p:cNvPr id="4" name="Rectangle 3"/>
+          <p:cNvSpPr/>
+          <p:nvPr/>
+        </p:nvSpPr>
+        <p:spPr>
+          <a:xfrm>
+            <a:off x="914400" y="4114800"/>
+            <a:ext cx="7315200" cy="73152"/>
+          </a:xfrm>
+          <a:prstGeom prst="rect">
+            <a:avLst/>
+          </a:prstGeom>
+          <a:solidFill>
+            <a:srgbClr val="DC2626"/>
+          </a:solidFill>
+        </p:spPr>
+        <p:style>
+          <a:lnRef idx="1">
+            <a:schemeClr val="accent1"/>
+          </a:lnRef>
+          <a:fillRef idx="3">
+            <a:schemeClr val="accent1"/>
+          </a:fillRef>
+          <a:effectRef idx="2">
+            <a:schemeClr val="accent1"/>
+          </a:effectRef>
+          <a:fontRef idx="minor">
+            <a:schemeClr val="lt1"/>
+          </a:fontRef>
+        </p:style>
+        <p:txBody>
+          <a:bodyPr rtlCol="0" anchor="ctr"/>
+          <a:lstStyle/>
+          <a:p>
+            <a:pPr algn="ctr"/>
           </a:p>
         </p:txBody>
       </p:sp>
@@ -4846,7 +5136,7 @@
     <p:bg>
       <p:bgPr>
         <a:solidFill>
-          <a:srgbClr val="F1F5F9"/>
+          <a:srgbClr val="F8FAFC"/>
         </a:solidFill>
         <a:effectLst/>
       </p:bgPr>
@@ -4874,14 +5164,14 @@
           <a:lstStyle/>
           <a:p>
             <a:pPr>
-              <a:defRPr>
-                <a:solidFill>
-                  <a:srgbClr val="1E293B"/>
+              <a:defRPr b="1" sz="3600">
+                <a:solidFill>
+                  <a:srgbClr val="DAA520"/>
                 </a:solidFill>
               </a:defRPr>
             </a:pPr>
             <a:r>
-              <a:t>Recherche &amp; Jurisprudence</a:t>
+              <a:t>La Bible des Modèles d'Élite</a:t>
             </a:r>
           </a:p>
         </p:txBody>
@@ -4903,50 +5193,183 @@
           <a:p/>
           <a:p>
             <a:pPr>
-              <a:defRPr sz="2000">
-                <a:solidFill>
-                  <a:srgbClr val="334155"/>
+              <a:spcAft>
+                <a:spcPts val="1200"/>
+              </a:spcAft>
+              <a:defRPr sz="1900">
+                <a:solidFill>
+                  <a:srgbClr val="0F172A"/>
                 </a:solidFill>
               </a:defRPr>
             </a:pPr>
             <a:r>
-              <a:t>Accès instantané aux précédents judiciaires.</a:t>
+              <a:t>◈ Base de Connaissances Unifiée : Centralisez les contrats-types et mémoires.</a:t>
             </a:r>
           </a:p>
           <a:p>
             <a:pPr>
-              <a:defRPr sz="2000">
-                <a:solidFill>
-                  <a:srgbClr val="334155"/>
+              <a:spcAft>
+                <a:spcPts val="1200"/>
+              </a:spcAft>
+              <a:defRPr sz="1900">
+                <a:solidFill>
+                  <a:srgbClr val="0F172A"/>
                 </a:solidFill>
               </a:defRPr>
             </a:pPr>
             <a:r>
-              <a:t>Moteur de recherche sémantique LexPremium.</a:t>
+              <a:t>◈ Catégorisation par Spécialité : Droit Civil, Commercial (OHADA), Pénal, Social.</a:t>
             </a:r>
           </a:p>
           <a:p>
             <a:pPr>
-              <a:defRPr sz="2000">
-                <a:solidFill>
-                  <a:srgbClr val="334155"/>
+              <a:spcAft>
+                <a:spcPts val="1200"/>
+              </a:spcAft>
+              <a:defRPr sz="1900">
+                <a:solidFill>
+                  <a:srgbClr val="0F172A"/>
                 </a:solidFill>
               </a:defRPr>
             </a:pPr>
             <a:r>
-              <a:t>Surveillance des évolutions législatives (OHADA).</a:t>
+              <a:t>◈ Modèles Dynamiques : Insertion automatique des données clients et dossiers.</a:t>
             </a:r>
           </a:p>
           <a:p>
             <a:pPr>
-              <a:defRPr sz="2000">
-                <a:solidFill>
-                  <a:srgbClr val="334155"/>
+              <a:spcAft>
+                <a:spcPts val="1200"/>
+              </a:spcAft>
+              <a:defRPr sz="1900">
+                <a:solidFill>
+                  <a:srgbClr val="0F172A"/>
                 </a:solidFill>
               </a:defRPr>
             </a:pPr>
             <a:r>
-              <a:t>Bibliothèque de droit comparé.</a:t>
+              <a:t>◈ Capitalisation du Savoir : Chaque bon acte devient un modèle pour le futur.</a:t>
+            </a:r>
+          </a:p>
+        </p:txBody>
+      </p:sp>
+      <p:sp>
+        <p:nvSpPr>
+          <p:cNvPr id="4" name="Rectangle 3"/>
+          <p:cNvSpPr/>
+          <p:nvPr/>
+        </p:nvSpPr>
+        <p:spPr>
+          <a:xfrm>
+            <a:off x="0" y="0"/>
+            <a:ext cx="9144000" cy="731520"/>
+          </a:xfrm>
+          <a:prstGeom prst="rect">
+            <a:avLst/>
+          </a:prstGeom>
+          <a:solidFill>
+            <a:srgbClr val="0F172A"/>
+          </a:solidFill>
+          <a:ln>
+            <a:noFill/>
+          </a:ln>
+        </p:spPr>
+        <p:style>
+          <a:lnRef idx="1">
+            <a:schemeClr val="accent1"/>
+          </a:lnRef>
+          <a:fillRef idx="3">
+            <a:schemeClr val="accent1"/>
+          </a:fillRef>
+          <a:effectRef idx="2">
+            <a:schemeClr val="accent1"/>
+          </a:effectRef>
+          <a:fontRef idx="minor">
+            <a:schemeClr val="lt1"/>
+          </a:fontRef>
+        </p:style>
+        <p:txBody>
+          <a:bodyPr rtlCol="0" anchor="ctr"/>
+          <a:lstStyle/>
+          <a:p>
+            <a:pPr algn="ctr"/>
+          </a:p>
+        </p:txBody>
+      </p:sp>
+      <p:sp>
+        <p:nvSpPr>
+          <p:cNvPr id="5" name="Rectangle 4"/>
+          <p:cNvSpPr/>
+          <p:nvPr/>
+        </p:nvSpPr>
+        <p:spPr>
+          <a:xfrm>
+            <a:off x="0" y="731520"/>
+            <a:ext cx="182880" cy="6126480"/>
+          </a:xfrm>
+          <a:prstGeom prst="rect">
+            <a:avLst/>
+          </a:prstGeom>
+          <a:solidFill>
+            <a:srgbClr val="DC2626"/>
+          </a:solidFill>
+          <a:ln>
+            <a:noFill/>
+          </a:ln>
+        </p:spPr>
+        <p:style>
+          <a:lnRef idx="1">
+            <a:schemeClr val="accent1"/>
+          </a:lnRef>
+          <a:fillRef idx="3">
+            <a:schemeClr val="accent1"/>
+          </a:fillRef>
+          <a:effectRef idx="2">
+            <a:schemeClr val="accent1"/>
+          </a:effectRef>
+          <a:fontRef idx="minor">
+            <a:schemeClr val="lt1"/>
+          </a:fontRef>
+        </p:style>
+        <p:txBody>
+          <a:bodyPr rtlCol="0" anchor="ctr"/>
+          <a:lstStyle/>
+          <a:p>
+            <a:pPr algn="ctr"/>
+          </a:p>
+        </p:txBody>
+      </p:sp>
+      <p:sp>
+        <p:nvSpPr>
+          <p:cNvPr id="6" name="TextBox 5"/>
+          <p:cNvSpPr txBox="1"/>
+          <p:nvPr/>
+        </p:nvSpPr>
+        <p:spPr>
+          <a:xfrm>
+            <a:off x="548640" y="914400"/>
+            <a:ext cx="8229600" cy="457200"/>
+          </a:xfrm>
+          <a:prstGeom prst="rect">
+            <a:avLst/>
+          </a:prstGeom>
+          <a:noFill/>
+        </p:spPr>
+        <p:txBody>
+          <a:bodyPr wrap="none">
+            <a:spAutoFit/>
+          </a:bodyPr>
+          <a:lstStyle/>
+          <a:p>
+            <a:pPr>
+              <a:defRPr sz="1800" b="1">
+                <a:solidFill>
+                  <a:srgbClr val="0F172A"/>
+                </a:solidFill>
+              </a:defRPr>
+            </a:pPr>
+            <a:r>
+              <a:t>Standardisez l'Excellence du Cabinet</a:t>
             </a:r>
           </a:p>
         </p:txBody>
@@ -4965,7 +5388,7 @@
     <p:bg>
       <p:bgPr>
         <a:solidFill>
-          <a:srgbClr val="F1F5F9"/>
+          <a:srgbClr val="F8FAFC"/>
         </a:solidFill>
         <a:effectLst/>
       </p:bgPr>
@@ -4993,14 +5416,14 @@
           <a:lstStyle/>
           <a:p>
             <a:pPr>
-              <a:defRPr>
-                <a:solidFill>
-                  <a:srgbClr val="1E293B"/>
+              <a:defRPr b="1" sz="3600">
+                <a:solidFill>
+                  <a:srgbClr val="DAA520"/>
                 </a:solidFill>
               </a:defRPr>
             </a:pPr>
             <a:r>
-              <a:t>Le 'War Room' de l'Audience</a:t>
+              <a:t>Aide à la Rédaction IA</a:t>
             </a:r>
           </a:p>
         </p:txBody>
@@ -5022,50 +5445,183 @@
           <a:p/>
           <a:p>
             <a:pPr>
-              <a:defRPr sz="2000">
-                <a:solidFill>
-                  <a:srgbClr val="334155"/>
+              <a:spcAft>
+                <a:spcPts val="1200"/>
+              </a:spcAft>
+              <a:defRPr sz="1900">
+                <a:solidFill>
+                  <a:srgbClr val="0F172A"/>
                 </a:solidFill>
               </a:defRPr>
             </a:pPr>
             <a:r>
-              <a:t>Chronomètre de Plaidoirie intégré.</a:t>
+              <a:t>◈ Générateur d'Actes : 75% du travail de structure fait par l'IA en 3 clics.</a:t>
             </a:r>
           </a:p>
           <a:p>
             <a:pPr>
-              <a:defRPr sz="2000">
-                <a:solidFill>
-                  <a:srgbClr val="334155"/>
+              <a:spcAft>
+                <a:spcPts val="1200"/>
+              </a:spcAft>
+              <a:defRPr sz="1900">
+                <a:solidFill>
+                  <a:srgbClr val="0F172A"/>
                 </a:solidFill>
               </a:defRPr>
             </a:pPr>
             <a:r>
-              <a:t>Mode Palais : Accès rapide aux pièces sur smartphone.</a:t>
+              <a:t>◈ Bibliothèque de Clauses : Insérez des clauses sécurisées et testées légalement.</a:t>
             </a:r>
           </a:p>
           <a:p>
             <a:pPr>
-              <a:defRPr sz="2000">
-                <a:solidFill>
-                  <a:srgbClr val="334155"/>
+              <a:spcAft>
+                <a:spcPts val="1200"/>
+              </a:spcAft>
+              <a:defRPr sz="1900">
+                <a:solidFill>
+                  <a:srgbClr val="0F172A"/>
                 </a:solidFill>
               </a:defRPr>
             </a:pPr>
             <a:r>
-              <a:t>Notes de plaidoirie interactives.</a:t>
+              <a:t>◈ Auto-Correction Juridique : Détection des incohérences et des oublis légaux.</a:t>
             </a:r>
           </a:p>
           <a:p>
             <a:pPr>
-              <a:defRPr sz="2000">
-                <a:solidFill>
-                  <a:srgbClr val="334155"/>
+              <a:spcAft>
+                <a:spcPts val="1200"/>
+              </a:spcAft>
+              <a:defRPr sz="1900">
+                <a:solidFill>
+                  <a:srgbClr val="0F172A"/>
                 </a:solidFill>
               </a:defRPr>
             </a:pPr>
             <a:r>
-              <a:t>Consultation hors-ligne au tribunal.</a:t>
+              <a:t>◈ Adaptation Contextuelle : L'IA ajuste les termes selon la juridiction visée.</a:t>
+            </a:r>
+          </a:p>
+        </p:txBody>
+      </p:sp>
+      <p:sp>
+        <p:nvSpPr>
+          <p:cNvPr id="4" name="Rectangle 3"/>
+          <p:cNvSpPr/>
+          <p:nvPr/>
+        </p:nvSpPr>
+        <p:spPr>
+          <a:xfrm>
+            <a:off x="0" y="0"/>
+            <a:ext cx="9144000" cy="731520"/>
+          </a:xfrm>
+          <a:prstGeom prst="rect">
+            <a:avLst/>
+          </a:prstGeom>
+          <a:solidFill>
+            <a:srgbClr val="0F172A"/>
+          </a:solidFill>
+          <a:ln>
+            <a:noFill/>
+          </a:ln>
+        </p:spPr>
+        <p:style>
+          <a:lnRef idx="1">
+            <a:schemeClr val="accent1"/>
+          </a:lnRef>
+          <a:fillRef idx="3">
+            <a:schemeClr val="accent1"/>
+          </a:fillRef>
+          <a:effectRef idx="2">
+            <a:schemeClr val="accent1"/>
+          </a:effectRef>
+          <a:fontRef idx="minor">
+            <a:schemeClr val="lt1"/>
+          </a:fontRef>
+        </p:style>
+        <p:txBody>
+          <a:bodyPr rtlCol="0" anchor="ctr"/>
+          <a:lstStyle/>
+          <a:p>
+            <a:pPr algn="ctr"/>
+          </a:p>
+        </p:txBody>
+      </p:sp>
+      <p:sp>
+        <p:nvSpPr>
+          <p:cNvPr id="5" name="Rectangle 4"/>
+          <p:cNvSpPr/>
+          <p:nvPr/>
+        </p:nvSpPr>
+        <p:spPr>
+          <a:xfrm>
+            <a:off x="0" y="731520"/>
+            <a:ext cx="182880" cy="6126480"/>
+          </a:xfrm>
+          <a:prstGeom prst="rect">
+            <a:avLst/>
+          </a:prstGeom>
+          <a:solidFill>
+            <a:srgbClr val="DC2626"/>
+          </a:solidFill>
+          <a:ln>
+            <a:noFill/>
+          </a:ln>
+        </p:spPr>
+        <p:style>
+          <a:lnRef idx="1">
+            <a:schemeClr val="accent1"/>
+          </a:lnRef>
+          <a:fillRef idx="3">
+            <a:schemeClr val="accent1"/>
+          </a:fillRef>
+          <a:effectRef idx="2">
+            <a:schemeClr val="accent1"/>
+          </a:effectRef>
+          <a:fontRef idx="minor">
+            <a:schemeClr val="lt1"/>
+          </a:fontRef>
+        </p:style>
+        <p:txBody>
+          <a:bodyPr rtlCol="0" anchor="ctr"/>
+          <a:lstStyle/>
+          <a:p>
+            <a:pPr algn="ctr"/>
+          </a:p>
+        </p:txBody>
+      </p:sp>
+      <p:sp>
+        <p:nvSpPr>
+          <p:cNvPr id="6" name="TextBox 5"/>
+          <p:cNvSpPr txBox="1"/>
+          <p:nvPr/>
+        </p:nvSpPr>
+        <p:spPr>
+          <a:xfrm>
+            <a:off x="548640" y="914400"/>
+            <a:ext cx="8229600" cy="457200"/>
+          </a:xfrm>
+          <a:prstGeom prst="rect">
+            <a:avLst/>
+          </a:prstGeom>
+          <a:noFill/>
+        </p:spPr>
+        <p:txBody>
+          <a:bodyPr wrap="none">
+            <a:spAutoFit/>
+          </a:bodyPr>
+          <a:lstStyle/>
+          <a:p>
+            <a:pPr>
+              <a:defRPr sz="1800" b="1">
+                <a:solidFill>
+                  <a:srgbClr val="0F172A"/>
+                </a:solidFill>
+              </a:defRPr>
+            </a:pPr>
+            <a:r>
+              <a:t>Rédigez à la Vitesse de la Pensée</a:t>
             </a:r>
           </a:p>
         </p:txBody>
@@ -5084,7 +5640,7 @@
     <p:bg>
       <p:bgPr>
         <a:solidFill>
-          <a:srgbClr val="F1F5F9"/>
+          <a:srgbClr val="000000"/>
         </a:solidFill>
         <a:effectLst/>
       </p:bgPr>
@@ -5112,80 +5668,72 @@
           <a:lstStyle/>
           <a:p>
             <a:pPr>
-              <a:defRPr>
-                <a:solidFill>
-                  <a:srgbClr val="1E293B"/>
+              <a:defRPr b="1" sz="5000">
+                <a:solidFill>
+                  <a:srgbClr val="B8860B"/>
                 </a:solidFill>
               </a:defRPr>
             </a:pPr>
             <a:r>
-              <a:t>Gestion de Dossiers Next-Gen</a:t>
-            </a:r>
-          </a:p>
-        </p:txBody>
-      </p:sp>
-      <p:sp>
-        <p:nvSpPr>
-          <p:cNvPr id="3" name="Content Placeholder 2"/>
-          <p:cNvSpPr>
-            <a:spLocks noGrp="1"/>
-          </p:cNvSpPr>
-          <p:nvPr>
-            <p:ph idx="1"/>
-          </p:nvPr>
-        </p:nvSpPr>
-        <p:spPr/>
-        <p:txBody>
-          <a:bodyPr wrap="square"/>
+              <a:t>TITRE III : GESTION RH &amp; COMPTABILITÉ</a:t>
+            </a:r>
+          </a:p>
+        </p:txBody>
+      </p:sp>
+      <p:sp>
+        <p:nvSpPr>
+          <p:cNvPr id="3" name="Text Placeholder 2"/>
+          <p:cNvSpPr>
+            <a:spLocks noGrp="1"/>
+          </p:cNvSpPr>
+          <p:nvPr>
+            <p:ph type="body" idx="1"/>
+          </p:nvPr>
+        </p:nvSpPr>
+        <p:spPr/>
+        <p:txBody>
+          <a:bodyPr/>
           <a:lstStyle/>
           <a:p/>
-          <a:p>
-            <a:pPr>
-              <a:defRPr sz="2000">
-                <a:solidFill>
-                  <a:srgbClr val="334155"/>
-                </a:solidFill>
-              </a:defRPr>
-            </a:pPr>
-            <a:r>
-              <a:t>Chronologie interactive de la procédure.</a:t>
-            </a:r>
-          </a:p>
-          <a:p>
-            <a:pPr>
-              <a:defRPr sz="2000">
-                <a:solidFill>
-                  <a:srgbClr val="334155"/>
-                </a:solidFill>
-              </a:defRPr>
-            </a:pPr>
-            <a:r>
-              <a:t>Interconnexion dynamique des parties (Experts, Huissiers).</a:t>
-            </a:r>
-          </a:p>
-          <a:p>
-            <a:pPr>
-              <a:defRPr sz="2000">
-                <a:solidFill>
-                  <a:srgbClr val="334155"/>
-                </a:solidFill>
-              </a:defRPr>
-            </a:pPr>
-            <a:r>
-              <a:t>Suivi des délais légaux par étape.</a:t>
-            </a:r>
-          </a:p>
-          <a:p>
-            <a:pPr>
-              <a:defRPr sz="2000">
-                <a:solidFill>
-                  <a:srgbClr val="334155"/>
-                </a:solidFill>
-              </a:defRPr>
-            </a:pPr>
-            <a:r>
-              <a:t>Versioning complet des documents.</a:t>
-            </a:r>
+        </p:txBody>
+      </p:sp>
+      <p:sp>
+        <p:nvSpPr>
+          <p:cNvPr id="4" name="Rectangle 3"/>
+          <p:cNvSpPr/>
+          <p:nvPr/>
+        </p:nvSpPr>
+        <p:spPr>
+          <a:xfrm>
+            <a:off x="914400" y="4114800"/>
+            <a:ext cx="7315200" cy="73152"/>
+          </a:xfrm>
+          <a:prstGeom prst="rect">
+            <a:avLst/>
+          </a:prstGeom>
+          <a:solidFill>
+            <a:srgbClr val="DC2626"/>
+          </a:solidFill>
+        </p:spPr>
+        <p:style>
+          <a:lnRef idx="1">
+            <a:schemeClr val="accent1"/>
+          </a:lnRef>
+          <a:fillRef idx="3">
+            <a:schemeClr val="accent1"/>
+          </a:fillRef>
+          <a:effectRef idx="2">
+            <a:schemeClr val="accent1"/>
+          </a:effectRef>
+          <a:fontRef idx="minor">
+            <a:schemeClr val="lt1"/>
+          </a:fontRef>
+        </p:style>
+        <p:txBody>
+          <a:bodyPr rtlCol="0" anchor="ctr"/>
+          <a:lstStyle/>
+          <a:p>
+            <a:pPr algn="ctr"/>
           </a:p>
         </p:txBody>
       </p:sp>

</xml_diff>